<commit_message>
Publish v2 results and competition dashboard
Add updated DINOv2 v2 results, multi-seed artifacts, competition dashboard, README update, and GitHub Pages entry.
</commit_message>
<xml_diff>
--- a/07_paper_draft/Project_A_LOCO_Presentation.pptx
+++ b/07_paper_draft/Project_A_LOCO_Presentation.pptx
@@ -1,23 +1,23 @@
 
 <file path=ppt/presentation.xml><?xml version="1.0" encoding="utf-8"?>
-<p:presentation xmlns:a="http://schemas.openxmlformats.org/drawingml/2006/main" xmlns:r="http://schemas.openxmlformats.org/officeDocument/2006/relationships" xmlns:p="http://schemas.openxmlformats.org/presentationml/2006/main" saveSubsetFonts="1" autoCompressPictures="0">
+<p:presentation xmlns:a="http://schemas.openxmlformats.org/drawingml/2006/main" xmlns:r="http://schemas.openxmlformats.org/officeDocument/2006/relationships" xmlns:p="http://schemas.openxmlformats.org/presentationml/2006/main" autoCompressPictures="0">
   <p:sldMasterIdLst>
     <p:sldMasterId id="2147483648" r:id="rId1"/>
   </p:sldMasterIdLst>
   <p:sldIdLst>
-    <p:sldId id="256" r:id="rId7"/>
-    <p:sldId id="257" r:id="rId8"/>
-    <p:sldId id="258" r:id="rId9"/>
-    <p:sldId id="259" r:id="rId10"/>
-    <p:sldId id="260" r:id="rId11"/>
-    <p:sldId id="261" r:id="rId12"/>
-    <p:sldId id="262" r:id="rId13"/>
-    <p:sldId id="263" r:id="rId14"/>
-    <p:sldId id="264" r:id="rId15"/>
-    <p:sldId id="265" r:id="rId16"/>
-    <p:sldId id="266" r:id="rId17"/>
+    <p:sldId id="256" r:id="rId3"/>
+    <p:sldId id="257" r:id="rId4"/>
+    <p:sldId id="258" r:id="rId5"/>
+    <p:sldId id="259" r:id="rId6"/>
+    <p:sldId id="260" r:id="rId7"/>
+    <p:sldId id="261" r:id="rId8"/>
+    <p:sldId id="262" r:id="rId9"/>
+    <p:sldId id="263" r:id="rId10"/>
+    <p:sldId id="264" r:id="rId11"/>
+    <p:sldId id="265" r:id="rId12"/>
+    <p:sldId id="266" r:id="rId13"/>
   </p:sldIdLst>
-  <p:sldSz cx="12191695" cy="6858000" type="screen4x3"/>
+  <p:sldSz cx="12191365" cy="6858000" type="screen4x3"/>
   <p:notesSz cx="6858000" cy="9144000"/>
   <p:defaultTextStyle>
     <a:defPPr>
@@ -114,6 +114,22 @@
       </a:defRPr>
     </a:lvl9pPr>
   </p:defaultTextStyle>
+  <p:extLst>
+    <p:ext uri="{EFAFB233-063F-42B5-8137-9DF3F51BA10A}">
+      <p15:sldGuideLst xmlns:p15="http://schemas.microsoft.com/office/powerpoint/2012/main">
+        <p15:guide id="1" orient="horz" pos="2160" userDrawn="1">
+          <p15:clr>
+            <a:srgbClr val="A4A3A4"/>
+          </p15:clr>
+        </p15:guide>
+        <p15:guide id="2" pos="2880" userDrawn="1">
+          <p15:clr>
+            <a:srgbClr val="A4A3A4"/>
+          </p15:clr>
+        </p15:guide>
+      </p15:sldGuideLst>
+    </p:ext>
+  </p:extLst>
 </p:presentation>
 </file>
 
@@ -298,7 +314,6 @@
           <a:p>
             <a:fld id="{5BCAD085-E8A6-8845-BD4E-CB4CCA059FC4}" type="datetimeFigureOut">
               <a:rPr lang="en-US" smtClean="0"/>
-              <a:t>1/27/13</a:t>
             </a:fld>
             <a:endParaRPr lang="en-US"/>
           </a:p>
@@ -340,18 +355,12 @@
           <a:p>
             <a:fld id="{C1FF6DA9-008F-8B48-92A6-B652298478BF}" type="slidenum">
               <a:rPr lang="en-US" smtClean="0"/>
-              <a:t>‹#›</a:t>
             </a:fld>
             <a:endParaRPr lang="en-US"/>
           </a:p>
         </p:txBody>
       </p:sp>
     </p:spTree>
-    <p:extLst>
-      <p:ext uri="{BB962C8B-B14F-4D97-AF65-F5344CB8AC3E}">
-        <p14:creationId xmlns:p14="http://schemas.microsoft.com/office/powerpoint/2010/main" val="3168075583"/>
-      </p:ext>
-    </p:extLst>
   </p:cSld>
   <p:clrMapOvr>
     <a:masterClrMapping/>
@@ -419,6 +428,7 @@
               <a:rPr lang="en-US" smtClean="0"/>
               <a:t>Click to edit Master text styles</a:t>
             </a:r>
+            <a:endParaRPr lang="en-US" smtClean="0"/>
           </a:p>
           <a:p>
             <a:pPr lvl="1"/>
@@ -426,6 +436,7 @@
               <a:rPr lang="en-US" smtClean="0"/>
               <a:t>Second level</a:t>
             </a:r>
+            <a:endParaRPr lang="en-US" smtClean="0"/>
           </a:p>
           <a:p>
             <a:pPr lvl="2"/>
@@ -433,6 +444,7 @@
               <a:rPr lang="en-US" smtClean="0"/>
               <a:t>Third level</a:t>
             </a:r>
+            <a:endParaRPr lang="en-US" smtClean="0"/>
           </a:p>
           <a:p>
             <a:pPr lvl="3"/>
@@ -440,6 +452,7 @@
               <a:rPr lang="en-US" smtClean="0"/>
               <a:t>Fourth level</a:t>
             </a:r>
+            <a:endParaRPr lang="en-US" smtClean="0"/>
           </a:p>
           <a:p>
             <a:pPr lvl="4"/>
@@ -468,7 +481,6 @@
           <a:p>
             <a:fld id="{5BCAD085-E8A6-8845-BD4E-CB4CCA059FC4}" type="datetimeFigureOut">
               <a:rPr lang="en-US" smtClean="0"/>
-              <a:t>1/27/13</a:t>
             </a:fld>
             <a:endParaRPr lang="en-US"/>
           </a:p>
@@ -510,18 +522,12 @@
           <a:p>
             <a:fld id="{C1FF6DA9-008F-8B48-92A6-B652298478BF}" type="slidenum">
               <a:rPr lang="en-US" smtClean="0"/>
-              <a:t>‹#›</a:t>
             </a:fld>
             <a:endParaRPr lang="en-US"/>
           </a:p>
         </p:txBody>
       </p:sp>
     </p:spTree>
-    <p:extLst>
-      <p:ext uri="{BB962C8B-B14F-4D97-AF65-F5344CB8AC3E}">
-        <p14:creationId xmlns:p14="http://schemas.microsoft.com/office/powerpoint/2010/main" val="2910927964"/>
-      </p:ext>
-    </p:extLst>
   </p:cSld>
   <p:clrMapOvr>
     <a:masterClrMapping/>
@@ -599,6 +605,7 @@
               <a:rPr lang="en-US" smtClean="0"/>
               <a:t>Click to edit Master text styles</a:t>
             </a:r>
+            <a:endParaRPr lang="en-US" smtClean="0"/>
           </a:p>
           <a:p>
             <a:pPr lvl="1"/>
@@ -606,6 +613,7 @@
               <a:rPr lang="en-US" smtClean="0"/>
               <a:t>Second level</a:t>
             </a:r>
+            <a:endParaRPr lang="en-US" smtClean="0"/>
           </a:p>
           <a:p>
             <a:pPr lvl="2"/>
@@ -613,6 +621,7 @@
               <a:rPr lang="en-US" smtClean="0"/>
               <a:t>Third level</a:t>
             </a:r>
+            <a:endParaRPr lang="en-US" smtClean="0"/>
           </a:p>
           <a:p>
             <a:pPr lvl="3"/>
@@ -620,6 +629,7 @@
               <a:rPr lang="en-US" smtClean="0"/>
               <a:t>Fourth level</a:t>
             </a:r>
+            <a:endParaRPr lang="en-US" smtClean="0"/>
           </a:p>
           <a:p>
             <a:pPr lvl="4"/>
@@ -648,7 +658,6 @@
           <a:p>
             <a:fld id="{5BCAD085-E8A6-8845-BD4E-CB4CCA059FC4}" type="datetimeFigureOut">
               <a:rPr lang="en-US" smtClean="0"/>
-              <a:t>1/27/13</a:t>
             </a:fld>
             <a:endParaRPr lang="en-US"/>
           </a:p>
@@ -690,18 +699,12 @@
           <a:p>
             <a:fld id="{C1FF6DA9-008F-8B48-92A6-B652298478BF}" type="slidenum">
               <a:rPr lang="en-US" smtClean="0"/>
-              <a:t>‹#›</a:t>
             </a:fld>
             <a:endParaRPr lang="en-US"/>
           </a:p>
         </p:txBody>
       </p:sp>
     </p:spTree>
-    <p:extLst>
-      <p:ext uri="{BB962C8B-B14F-4D97-AF65-F5344CB8AC3E}">
-        <p14:creationId xmlns:p14="http://schemas.microsoft.com/office/powerpoint/2010/main" val="3612223792"/>
-      </p:ext>
-    </p:extLst>
   </p:cSld>
   <p:clrMapOvr>
     <a:masterClrMapping/>
@@ -769,6 +772,7 @@
               <a:rPr lang="en-US" smtClean="0"/>
               <a:t>Click to edit Master text styles</a:t>
             </a:r>
+            <a:endParaRPr lang="en-US" smtClean="0"/>
           </a:p>
           <a:p>
             <a:pPr lvl="1"/>
@@ -776,6 +780,7 @@
               <a:rPr lang="en-US" smtClean="0"/>
               <a:t>Second level</a:t>
             </a:r>
+            <a:endParaRPr lang="en-US" smtClean="0"/>
           </a:p>
           <a:p>
             <a:pPr lvl="2"/>
@@ -783,6 +788,7 @@
               <a:rPr lang="en-US" smtClean="0"/>
               <a:t>Third level</a:t>
             </a:r>
+            <a:endParaRPr lang="en-US" smtClean="0"/>
           </a:p>
           <a:p>
             <a:pPr lvl="3"/>
@@ -790,6 +796,7 @@
               <a:rPr lang="en-US" smtClean="0"/>
               <a:t>Fourth level</a:t>
             </a:r>
+            <a:endParaRPr lang="en-US" smtClean="0"/>
           </a:p>
           <a:p>
             <a:pPr lvl="4"/>
@@ -818,7 +825,6 @@
           <a:p>
             <a:fld id="{5BCAD085-E8A6-8845-BD4E-CB4CCA059FC4}" type="datetimeFigureOut">
               <a:rPr lang="en-US" smtClean="0"/>
-              <a:t>1/27/13</a:t>
             </a:fld>
             <a:endParaRPr lang="en-US"/>
           </a:p>
@@ -860,18 +866,12 @@
           <a:p>
             <a:fld id="{C1FF6DA9-008F-8B48-92A6-B652298478BF}" type="slidenum">
               <a:rPr lang="en-US" smtClean="0"/>
-              <a:t>‹#›</a:t>
             </a:fld>
             <a:endParaRPr lang="en-US"/>
           </a:p>
         </p:txBody>
       </p:sp>
     </p:spTree>
-    <p:extLst>
-      <p:ext uri="{BB962C8B-B14F-4D97-AF65-F5344CB8AC3E}">
-        <p14:creationId xmlns:p14="http://schemas.microsoft.com/office/powerpoint/2010/main" val="2614314258"/>
-      </p:ext>
-    </p:extLst>
   </p:cSld>
   <p:clrMapOvr>
     <a:masterClrMapping/>
@@ -1044,6 +1044,7 @@
               <a:rPr lang="en-US" smtClean="0"/>
               <a:t>Click to edit Master text styles</a:t>
             </a:r>
+            <a:endParaRPr lang="en-US" smtClean="0"/>
           </a:p>
         </p:txBody>
       </p:sp>
@@ -1064,7 +1065,6 @@
           <a:p>
             <a:fld id="{5BCAD085-E8A6-8845-BD4E-CB4CCA059FC4}" type="datetimeFigureOut">
               <a:rPr lang="en-US" smtClean="0"/>
-              <a:t>1/27/13</a:t>
             </a:fld>
             <a:endParaRPr lang="en-US"/>
           </a:p>
@@ -1106,18 +1106,12 @@
           <a:p>
             <a:fld id="{C1FF6DA9-008F-8B48-92A6-B652298478BF}" type="slidenum">
               <a:rPr lang="en-US" smtClean="0"/>
-              <a:t>‹#›</a:t>
             </a:fld>
             <a:endParaRPr lang="en-US"/>
           </a:p>
         </p:txBody>
       </p:sp>
     </p:spTree>
-    <p:extLst>
-      <p:ext uri="{BB962C8B-B14F-4D97-AF65-F5344CB8AC3E}">
-        <p14:creationId xmlns:p14="http://schemas.microsoft.com/office/powerpoint/2010/main" val="960648375"/>
-      </p:ext>
-    </p:extLst>
   </p:cSld>
   <p:clrMapOvr>
     <a:masterClrMapping/>
@@ -1218,6 +1212,7 @@
               <a:rPr lang="en-US" smtClean="0"/>
               <a:t>Click to edit Master text styles</a:t>
             </a:r>
+            <a:endParaRPr lang="en-US" smtClean="0"/>
           </a:p>
           <a:p>
             <a:pPr lvl="1"/>
@@ -1225,6 +1220,7 @@
               <a:rPr lang="en-US" smtClean="0"/>
               <a:t>Second level</a:t>
             </a:r>
+            <a:endParaRPr lang="en-US" smtClean="0"/>
           </a:p>
           <a:p>
             <a:pPr lvl="2"/>
@@ -1232,6 +1228,7 @@
               <a:rPr lang="en-US" smtClean="0"/>
               <a:t>Third level</a:t>
             </a:r>
+            <a:endParaRPr lang="en-US" smtClean="0"/>
           </a:p>
           <a:p>
             <a:pPr lvl="3"/>
@@ -1239,6 +1236,7 @@
               <a:rPr lang="en-US" smtClean="0"/>
               <a:t>Fourth level</a:t>
             </a:r>
+            <a:endParaRPr lang="en-US" smtClean="0"/>
           </a:p>
           <a:p>
             <a:pPr lvl="4"/>
@@ -1303,6 +1301,7 @@
               <a:rPr lang="en-US" smtClean="0"/>
               <a:t>Click to edit Master text styles</a:t>
             </a:r>
+            <a:endParaRPr lang="en-US" smtClean="0"/>
           </a:p>
           <a:p>
             <a:pPr lvl="1"/>
@@ -1310,6 +1309,7 @@
               <a:rPr lang="en-US" smtClean="0"/>
               <a:t>Second level</a:t>
             </a:r>
+            <a:endParaRPr lang="en-US" smtClean="0"/>
           </a:p>
           <a:p>
             <a:pPr lvl="2"/>
@@ -1317,6 +1317,7 @@
               <a:rPr lang="en-US" smtClean="0"/>
               <a:t>Third level</a:t>
             </a:r>
+            <a:endParaRPr lang="en-US" smtClean="0"/>
           </a:p>
           <a:p>
             <a:pPr lvl="3"/>
@@ -1324,6 +1325,7 @@
               <a:rPr lang="en-US" smtClean="0"/>
               <a:t>Fourth level</a:t>
             </a:r>
+            <a:endParaRPr lang="en-US" smtClean="0"/>
           </a:p>
           <a:p>
             <a:pPr lvl="4"/>
@@ -1352,7 +1354,6 @@
           <a:p>
             <a:fld id="{5BCAD085-E8A6-8845-BD4E-CB4CCA059FC4}" type="datetimeFigureOut">
               <a:rPr lang="en-US" smtClean="0"/>
-              <a:t>1/27/13</a:t>
             </a:fld>
             <a:endParaRPr lang="en-US"/>
           </a:p>
@@ -1394,18 +1395,12 @@
           <a:p>
             <a:fld id="{C1FF6DA9-008F-8B48-92A6-B652298478BF}" type="slidenum">
               <a:rPr lang="en-US" smtClean="0"/>
-              <a:t>‹#›</a:t>
             </a:fld>
             <a:endParaRPr lang="en-US"/>
           </a:p>
         </p:txBody>
       </p:sp>
     </p:spTree>
-    <p:extLst>
-      <p:ext uri="{BB962C8B-B14F-4D97-AF65-F5344CB8AC3E}">
-        <p14:creationId xmlns:p14="http://schemas.microsoft.com/office/powerpoint/2010/main" val="2782244947"/>
-      </p:ext>
-    </p:extLst>
   </p:cSld>
   <p:clrMapOvr>
     <a:masterClrMapping/>
@@ -1519,6 +1514,7 @@
               <a:rPr lang="en-US" smtClean="0"/>
               <a:t>Click to edit Master text styles</a:t>
             </a:r>
+            <a:endParaRPr lang="en-US" smtClean="0"/>
           </a:p>
         </p:txBody>
       </p:sp>
@@ -1575,6 +1571,7 @@
               <a:rPr lang="en-US" smtClean="0"/>
               <a:t>Click to edit Master text styles</a:t>
             </a:r>
+            <a:endParaRPr lang="en-US" smtClean="0"/>
           </a:p>
           <a:p>
             <a:pPr lvl="1"/>
@@ -1582,6 +1579,7 @@
               <a:rPr lang="en-US" smtClean="0"/>
               <a:t>Second level</a:t>
             </a:r>
+            <a:endParaRPr lang="en-US" smtClean="0"/>
           </a:p>
           <a:p>
             <a:pPr lvl="2"/>
@@ -1589,6 +1587,7 @@
               <a:rPr lang="en-US" smtClean="0"/>
               <a:t>Third level</a:t>
             </a:r>
+            <a:endParaRPr lang="en-US" smtClean="0"/>
           </a:p>
           <a:p>
             <a:pPr lvl="3"/>
@@ -1596,6 +1595,7 @@
               <a:rPr lang="en-US" smtClean="0"/>
               <a:t>Fourth level</a:t>
             </a:r>
+            <a:endParaRPr lang="en-US" smtClean="0"/>
           </a:p>
           <a:p>
             <a:pPr lvl="4"/>
@@ -1669,6 +1669,7 @@
               <a:rPr lang="en-US" smtClean="0"/>
               <a:t>Click to edit Master text styles</a:t>
             </a:r>
+            <a:endParaRPr lang="en-US" smtClean="0"/>
           </a:p>
         </p:txBody>
       </p:sp>
@@ -1725,6 +1726,7 @@
               <a:rPr lang="en-US" smtClean="0"/>
               <a:t>Click to edit Master text styles</a:t>
             </a:r>
+            <a:endParaRPr lang="en-US" smtClean="0"/>
           </a:p>
           <a:p>
             <a:pPr lvl="1"/>
@@ -1732,6 +1734,7 @@
               <a:rPr lang="en-US" smtClean="0"/>
               <a:t>Second level</a:t>
             </a:r>
+            <a:endParaRPr lang="en-US" smtClean="0"/>
           </a:p>
           <a:p>
             <a:pPr lvl="2"/>
@@ -1739,6 +1742,7 @@
               <a:rPr lang="en-US" smtClean="0"/>
               <a:t>Third level</a:t>
             </a:r>
+            <a:endParaRPr lang="en-US" smtClean="0"/>
           </a:p>
           <a:p>
             <a:pPr lvl="3"/>
@@ -1746,6 +1750,7 @@
               <a:rPr lang="en-US" smtClean="0"/>
               <a:t>Fourth level</a:t>
             </a:r>
+            <a:endParaRPr lang="en-US" smtClean="0"/>
           </a:p>
           <a:p>
             <a:pPr lvl="4"/>
@@ -1774,7 +1779,6 @@
           <a:p>
             <a:fld id="{5BCAD085-E8A6-8845-BD4E-CB4CCA059FC4}" type="datetimeFigureOut">
               <a:rPr lang="en-US" smtClean="0"/>
-              <a:t>1/27/13</a:t>
             </a:fld>
             <a:endParaRPr lang="en-US"/>
           </a:p>
@@ -1816,18 +1820,12 @@
           <a:p>
             <a:fld id="{C1FF6DA9-008F-8B48-92A6-B652298478BF}" type="slidenum">
               <a:rPr lang="en-US" smtClean="0"/>
-              <a:t>‹#›</a:t>
             </a:fld>
             <a:endParaRPr lang="en-US"/>
           </a:p>
         </p:txBody>
       </p:sp>
     </p:spTree>
-    <p:extLst>
-      <p:ext uri="{BB962C8B-B14F-4D97-AF65-F5344CB8AC3E}">
-        <p14:creationId xmlns:p14="http://schemas.microsoft.com/office/powerpoint/2010/main" val="990158736"/>
-      </p:ext>
-    </p:extLst>
   </p:cSld>
   <p:clrMapOvr>
     <a:masterClrMapping/>
@@ -1892,7 +1890,6 @@
           <a:p>
             <a:fld id="{5BCAD085-E8A6-8845-BD4E-CB4CCA059FC4}" type="datetimeFigureOut">
               <a:rPr lang="en-US" smtClean="0"/>
-              <a:t>1/27/13</a:t>
             </a:fld>
             <a:endParaRPr lang="en-US"/>
           </a:p>
@@ -1934,18 +1931,12 @@
           <a:p>
             <a:fld id="{C1FF6DA9-008F-8B48-92A6-B652298478BF}" type="slidenum">
               <a:rPr lang="en-US" smtClean="0"/>
-              <a:t>‹#›</a:t>
             </a:fld>
             <a:endParaRPr lang="en-US"/>
           </a:p>
         </p:txBody>
       </p:sp>
     </p:spTree>
-    <p:extLst>
-      <p:ext uri="{BB962C8B-B14F-4D97-AF65-F5344CB8AC3E}">
-        <p14:creationId xmlns:p14="http://schemas.microsoft.com/office/powerpoint/2010/main" val="727027711"/>
-      </p:ext>
-    </p:extLst>
   </p:cSld>
   <p:clrMapOvr>
     <a:masterClrMapping/>
@@ -1987,7 +1978,6 @@
           <a:p>
             <a:fld id="{5BCAD085-E8A6-8845-BD4E-CB4CCA059FC4}" type="datetimeFigureOut">
               <a:rPr lang="en-US" smtClean="0"/>
-              <a:t>1/27/13</a:t>
             </a:fld>
             <a:endParaRPr lang="en-US"/>
           </a:p>
@@ -2029,18 +2019,12 @@
           <a:p>
             <a:fld id="{C1FF6DA9-008F-8B48-92A6-B652298478BF}" type="slidenum">
               <a:rPr lang="en-US" smtClean="0"/>
-              <a:t>‹#›</a:t>
             </a:fld>
             <a:endParaRPr lang="en-US"/>
           </a:p>
         </p:txBody>
       </p:sp>
     </p:spTree>
-    <p:extLst>
-      <p:ext uri="{BB962C8B-B14F-4D97-AF65-F5344CB8AC3E}">
-        <p14:creationId xmlns:p14="http://schemas.microsoft.com/office/powerpoint/2010/main" val="1212999818"/>
-      </p:ext>
-    </p:extLst>
   </p:cSld>
   <p:clrMapOvr>
     <a:masterClrMapping/>
@@ -2150,6 +2134,7 @@
               <a:rPr lang="en-US" smtClean="0"/>
               <a:t>Click to edit Master text styles</a:t>
             </a:r>
+            <a:endParaRPr lang="en-US" smtClean="0"/>
           </a:p>
           <a:p>
             <a:pPr lvl="1"/>
@@ -2157,6 +2142,7 @@
               <a:rPr lang="en-US" smtClean="0"/>
               <a:t>Second level</a:t>
             </a:r>
+            <a:endParaRPr lang="en-US" smtClean="0"/>
           </a:p>
           <a:p>
             <a:pPr lvl="2"/>
@@ -2164,6 +2150,7 @@
               <a:rPr lang="en-US" smtClean="0"/>
               <a:t>Third level</a:t>
             </a:r>
+            <a:endParaRPr lang="en-US" smtClean="0"/>
           </a:p>
           <a:p>
             <a:pPr lvl="3"/>
@@ -2171,6 +2158,7 @@
               <a:rPr lang="en-US" smtClean="0"/>
               <a:t>Fourth level</a:t>
             </a:r>
+            <a:endParaRPr lang="en-US" smtClean="0"/>
           </a:p>
           <a:p>
             <a:pPr lvl="4"/>
@@ -2244,6 +2232,7 @@
               <a:rPr lang="en-US" smtClean="0"/>
               <a:t>Click to edit Master text styles</a:t>
             </a:r>
+            <a:endParaRPr lang="en-US" smtClean="0"/>
           </a:p>
         </p:txBody>
       </p:sp>
@@ -2264,7 +2253,6 @@
           <a:p>
             <a:fld id="{5BCAD085-E8A6-8845-BD4E-CB4CCA059FC4}" type="datetimeFigureOut">
               <a:rPr lang="en-US" smtClean="0"/>
-              <a:t>1/27/13</a:t>
             </a:fld>
             <a:endParaRPr lang="en-US"/>
           </a:p>
@@ -2306,18 +2294,12 @@
           <a:p>
             <a:fld id="{C1FF6DA9-008F-8B48-92A6-B652298478BF}" type="slidenum">
               <a:rPr lang="en-US" smtClean="0"/>
-              <a:t>‹#›</a:t>
             </a:fld>
             <a:endParaRPr lang="en-US"/>
           </a:p>
         </p:txBody>
       </p:sp>
     </p:spTree>
-    <p:extLst>
-      <p:ext uri="{BB962C8B-B14F-4D97-AF65-F5344CB8AC3E}">
-        <p14:creationId xmlns:p14="http://schemas.microsoft.com/office/powerpoint/2010/main" val="1840726560"/>
-      </p:ext>
-    </p:extLst>
   </p:cSld>
   <p:clrMapOvr>
     <a:masterClrMapping/>
@@ -2497,6 +2479,7 @@
               <a:rPr lang="en-US" smtClean="0"/>
               <a:t>Click to edit Master text styles</a:t>
             </a:r>
+            <a:endParaRPr lang="en-US" smtClean="0"/>
           </a:p>
         </p:txBody>
       </p:sp>
@@ -2517,7 +2500,6 @@
           <a:p>
             <a:fld id="{5BCAD085-E8A6-8845-BD4E-CB4CCA059FC4}" type="datetimeFigureOut">
               <a:rPr lang="en-US" smtClean="0"/>
-              <a:t>1/27/13</a:t>
             </a:fld>
             <a:endParaRPr lang="en-US"/>
           </a:p>
@@ -2559,18 +2541,12 @@
           <a:p>
             <a:fld id="{C1FF6DA9-008F-8B48-92A6-B652298478BF}" type="slidenum">
               <a:rPr lang="en-US" smtClean="0"/>
-              <a:t>‹#›</a:t>
             </a:fld>
             <a:endParaRPr lang="en-US"/>
           </a:p>
         </p:txBody>
       </p:sp>
     </p:spTree>
-    <p:extLst>
-      <p:ext uri="{BB962C8B-B14F-4D97-AF65-F5344CB8AC3E}">
-        <p14:creationId xmlns:p14="http://schemas.microsoft.com/office/powerpoint/2010/main" val="3889236939"/>
-      </p:ext>
-    </p:extLst>
   </p:cSld>
   <p:clrMapOvr>
     <a:masterClrMapping/>
@@ -2663,6 +2639,7 @@
               <a:rPr lang="en-US" smtClean="0"/>
               <a:t>Click to edit Master text styles</a:t>
             </a:r>
+            <a:endParaRPr lang="en-US" smtClean="0"/>
           </a:p>
           <a:p>
             <a:pPr lvl="1"/>
@@ -2670,6 +2647,7 @@
               <a:rPr lang="en-US" smtClean="0"/>
               <a:t>Second level</a:t>
             </a:r>
+            <a:endParaRPr lang="en-US" smtClean="0"/>
           </a:p>
           <a:p>
             <a:pPr lvl="2"/>
@@ -2677,6 +2655,7 @@
               <a:rPr lang="en-US" smtClean="0"/>
               <a:t>Third level</a:t>
             </a:r>
+            <a:endParaRPr lang="en-US" smtClean="0"/>
           </a:p>
           <a:p>
             <a:pPr lvl="3"/>
@@ -2684,6 +2663,7 @@
               <a:rPr lang="en-US" smtClean="0"/>
               <a:t>Fourth level</a:t>
             </a:r>
+            <a:endParaRPr lang="en-US" smtClean="0"/>
           </a:p>
           <a:p>
             <a:pPr lvl="4"/>
@@ -2730,7 +2710,6 @@
           <a:p>
             <a:fld id="{5BCAD085-E8A6-8845-BD4E-CB4CCA059FC4}" type="datetimeFigureOut">
               <a:rPr lang="en-US" smtClean="0"/>
-              <a:t>1/27/13</a:t>
             </a:fld>
             <a:endParaRPr lang="en-US"/>
           </a:p>
@@ -2808,18 +2787,12 @@
           <a:p>
             <a:fld id="{C1FF6DA9-008F-8B48-92A6-B652298478BF}" type="slidenum">
               <a:rPr lang="en-US" smtClean="0"/>
-              <a:t>‹#›</a:t>
             </a:fld>
             <a:endParaRPr lang="en-US"/>
           </a:p>
         </p:txBody>
       </p:sp>
     </p:spTree>
-    <p:extLst>
-      <p:ext uri="{BB962C8B-B14F-4D97-AF65-F5344CB8AC3E}">
-        <p14:creationId xmlns:p14="http://schemas.microsoft.com/office/powerpoint/2010/main" val="2209977519"/>
-      </p:ext>
-    </p:extLst>
   </p:cSld>
   <p:clrMap bg1="lt1" tx1="dk1" bg2="lt2" tx2="dk2" accent1="accent1" accent2="accent2" accent3="accent3" accent4="accent4" accent5="accent5" accent6="accent6" hlink="hlink" folHlink="folHlink"/>
   <p:sldLayoutIdLst>
@@ -2857,7 +2830,7 @@
         <a:spcBef>
           <a:spcPct val="20000"/>
         </a:spcBef>
-        <a:buFont typeface="Arial"/>
+        <a:buFont typeface="Arial" panose="020B0604020202020204"/>
         <a:buChar char="•"/>
         <a:defRPr sz="3200" kern="1200">
           <a:solidFill>
@@ -2872,7 +2845,7 @@
         <a:spcBef>
           <a:spcPct val="20000"/>
         </a:spcBef>
-        <a:buFont typeface="Arial"/>
+        <a:buFont typeface="Arial" panose="020B0604020202020204"/>
         <a:buChar char="–"/>
         <a:defRPr sz="2800" kern="1200">
           <a:solidFill>
@@ -2887,7 +2860,7 @@
         <a:spcBef>
           <a:spcPct val="20000"/>
         </a:spcBef>
-        <a:buFont typeface="Arial"/>
+        <a:buFont typeface="Arial" panose="020B0604020202020204"/>
         <a:buChar char="•"/>
         <a:defRPr sz="2400" kern="1200">
           <a:solidFill>
@@ -2902,7 +2875,7 @@
         <a:spcBef>
           <a:spcPct val="20000"/>
         </a:spcBef>
-        <a:buFont typeface="Arial"/>
+        <a:buFont typeface="Arial" panose="020B0604020202020204"/>
         <a:buChar char="–"/>
         <a:defRPr sz="2000" kern="1200">
           <a:solidFill>
@@ -2917,7 +2890,7 @@
         <a:spcBef>
           <a:spcPct val="20000"/>
         </a:spcBef>
-        <a:buFont typeface="Arial"/>
+        <a:buFont typeface="Arial" panose="020B0604020202020204"/>
         <a:buChar char="»"/>
         <a:defRPr sz="2000" kern="1200">
           <a:solidFill>
@@ -2932,7 +2905,7 @@
         <a:spcBef>
           <a:spcPct val="20000"/>
         </a:spcBef>
-        <a:buFont typeface="Arial"/>
+        <a:buFont typeface="Arial" panose="020B0604020202020204"/>
         <a:buChar char="•"/>
         <a:defRPr sz="2000" kern="1200">
           <a:solidFill>
@@ -2947,7 +2920,7 @@
         <a:spcBef>
           <a:spcPct val="20000"/>
         </a:spcBef>
-        <a:buFont typeface="Arial"/>
+        <a:buFont typeface="Arial" panose="020B0604020202020204"/>
         <a:buChar char="•"/>
         <a:defRPr sz="2000" kern="1200">
           <a:solidFill>
@@ -2962,7 +2935,7 @@
         <a:spcBef>
           <a:spcPct val="20000"/>
         </a:spcBef>
-        <a:buFont typeface="Arial"/>
+        <a:buFont typeface="Arial" panose="020B0604020202020204"/>
         <a:buChar char="•"/>
         <a:defRPr sz="2000" kern="1200">
           <a:solidFill>
@@ -2977,7 +2950,7 @@
         <a:spcBef>
           <a:spcPct val="20000"/>
         </a:spcBef>
-        <a:buFont typeface="Arial"/>
+        <a:buFont typeface="Arial" panose="020B0604020202020204"/>
         <a:buChar char="•"/>
         <a:defRPr sz="2000" kern="1200">
           <a:solidFill>
@@ -3089,7 +3062,7 @@
 </file>
 
 <file path=ppt/slides/slide1.xml><?xml version="1.0" encoding="utf-8"?>
-<p:sld xmlns:a="http://schemas.openxmlformats.org/drawingml/2006/main" xmlns:p="http://schemas.openxmlformats.org/presentationml/2006/main" xmlns:r="http://schemas.openxmlformats.org/officeDocument/2006/relationships">
+<p:sld xmlns:a="http://schemas.openxmlformats.org/drawingml/2006/main" xmlns:r="http://schemas.openxmlformats.org/officeDocument/2006/relationships" xmlns:p="http://schemas.openxmlformats.org/presentationml/2006/main">
   <p:cSld>
     <p:bg>
       <p:bgPr>
@@ -3159,7 +3132,7 @@
         <p:spPr>
           <a:xfrm>
             <a:off x="914400" y="2148840"/>
-            <a:ext cx="10332720" cy="2011680"/>
+            <a:ext cx="10332720" cy="1536700"/>
           </a:xfrm>
           <a:prstGeom prst="rect">
             <a:avLst/>
@@ -3167,7 +3140,7 @@
           <a:noFill/>
         </p:spPr>
         <p:txBody>
-          <a:bodyPr wrap="square" lIns="45720" rIns="45720" tIns="27432" bIns="27432">
+          <a:bodyPr wrap="square" lIns="45720" tIns="27432" rIns="45720" bIns="27432">
             <a:spAutoFit/>
           </a:bodyPr>
           <a:lstStyle/>
@@ -3182,10 +3155,16 @@
                 <a:solidFill>
                   <a:srgbClr val="FFFFFF"/>
                 </a:solidFill>
-                <a:latin typeface="Trebuchet MS"/>
+                <a:latin typeface="Trebuchet MS" panose="020B0603020202020204"/>
               </a:rPr>
               <a:t>LOCO Anomaly Inspector</a:t>
             </a:r>
+            <a:endParaRPr sz="4600" b="1" i="0">
+              <a:solidFill>
+                <a:srgbClr val="FFFFFF"/>
+              </a:solidFill>
+              <a:latin typeface="Trebuchet MS" panose="020B0603020202020204"/>
+            </a:endParaRPr>
           </a:p>
           <a:p>
             <a:pPr algn="l">
@@ -3198,10 +3177,16 @@
                 <a:solidFill>
                   <a:srgbClr val="CADCFC"/>
                 </a:solidFill>
-                <a:latin typeface="Trebuchet MS"/>
+                <a:latin typeface="Trebuchet MS" panose="020B0603020202020204"/>
               </a:rPr>
               <a:t>An interactive, reproducible system for logical &amp; structural anomaly detection</a:t>
             </a:r>
+            <a:endParaRPr sz="2100" b="0" i="0">
+              <a:solidFill>
+                <a:srgbClr val="CADCFC"/>
+              </a:solidFill>
+              <a:latin typeface="Trebuchet MS" panose="020B0603020202020204"/>
+            </a:endParaRPr>
           </a:p>
           <a:p>
             <a:pPr algn="l">
@@ -3214,26 +3199,16 @@
                 <a:solidFill>
                   <a:srgbClr val="CADCFC"/>
                 </a:solidFill>
-                <a:latin typeface="Trebuchet MS"/>
+                <a:latin typeface="Trebuchet MS" panose="020B0603020202020204"/>
               </a:rPr>
               <a:t>on the MVTec LOCO AD industrial benchmark</a:t>
             </a:r>
-          </a:p>
-          <a:p>
-            <a:pPr algn="l">
-              <a:spcAft>
-                <a:spcPts val="600"/>
-              </a:spcAft>
-            </a:pPr>
-            <a:r>
-              <a:rPr sz="1400" b="1" i="0">
-                <a:solidFill>
-                  <a:srgbClr val="1AB3A3"/>
-                </a:solidFill>
-                <a:latin typeface="Calibri"/>
-              </a:rPr>
-              <a:t>Data Analytics Lab — Project A   •   Final Project Presentation</a:t>
-            </a:r>
+            <a:endParaRPr sz="1400" b="1" i="0">
+              <a:solidFill>
+                <a:srgbClr val="1AB3A3"/>
+              </a:solidFill>
+              <a:latin typeface="Calibri" panose="020F0502020204030204"/>
+            </a:endParaRPr>
           </a:p>
         </p:txBody>
       </p:sp>
@@ -3246,7 +3221,7 @@
 </file>
 
 <file path=ppt/slides/slide10.xml><?xml version="1.0" encoding="utf-8"?>
-<p:sld xmlns:a="http://schemas.openxmlformats.org/drawingml/2006/main" xmlns:p="http://schemas.openxmlformats.org/presentationml/2006/main" xmlns:r="http://schemas.openxmlformats.org/officeDocument/2006/relationships">
+<p:sld xmlns:a="http://schemas.openxmlformats.org/drawingml/2006/main" xmlns:r="http://schemas.openxmlformats.org/officeDocument/2006/relationships" xmlns:p="http://schemas.openxmlformats.org/presentationml/2006/main">
   <p:cSld>
     <p:bg>
       <p:bgPr>
@@ -3280,7 +3255,7 @@
           <a:noFill/>
         </p:spPr>
         <p:txBody>
-          <a:bodyPr wrap="square" lIns="45720" rIns="45720" tIns="27432" bIns="27432">
+          <a:bodyPr wrap="square" lIns="45720" tIns="27432" rIns="45720" bIns="27432">
             <a:spAutoFit/>
           </a:bodyPr>
           <a:lstStyle/>
@@ -3295,10 +3270,16 @@
                 <a:solidFill>
                   <a:srgbClr val="1F3A5F"/>
                 </a:solidFill>
-                <a:latin typeface="Trebuchet MS"/>
+                <a:latin typeface="Trebuchet MS" panose="020B0603020202020204"/>
               </a:rPr>
               <a:t>Honest about where we stand</a:t>
             </a:r>
+            <a:endParaRPr sz="3000" b="1" i="0">
+              <a:solidFill>
+                <a:srgbClr val="1F3A5F"/>
+              </a:solidFill>
+              <a:latin typeface="Trebuchet MS" panose="020B0603020202020204"/>
+            </a:endParaRPr>
           </a:p>
         </p:txBody>
       </p:sp>
@@ -3407,7 +3388,7 @@
           <a:noFill/>
         </p:spPr>
         <p:txBody>
-          <a:bodyPr wrap="square" lIns="45720" rIns="45720" tIns="27432" bIns="27432">
+          <a:bodyPr wrap="square" lIns="45720" tIns="27432" rIns="45720" bIns="27432">
             <a:spAutoFit/>
           </a:bodyPr>
           <a:lstStyle/>
@@ -3422,10 +3403,16 @@
                 <a:solidFill>
                   <a:srgbClr val="FFFFFF"/>
                 </a:solidFill>
-                <a:latin typeface="Trebuchet MS"/>
+                <a:latin typeface="Trebuchet MS" panose="020B0603020202020204"/>
               </a:rPr>
               <a:t>Ours — DINOv2 (now)</a:t>
             </a:r>
+            <a:endParaRPr sz="1600" b="1" i="0">
+              <a:solidFill>
+                <a:srgbClr val="FFFFFF"/>
+              </a:solidFill>
+              <a:latin typeface="Trebuchet MS" panose="020B0603020202020204"/>
+            </a:endParaRPr>
           </a:p>
         </p:txBody>
       </p:sp>
@@ -3446,7 +3433,7 @@
           <a:noFill/>
         </p:spPr>
         <p:txBody>
-          <a:bodyPr wrap="square" lIns="45720" rIns="45720" tIns="27432" bIns="27432">
+          <a:bodyPr wrap="square" lIns="45720" tIns="27432" rIns="45720" bIns="27432">
             <a:spAutoFit/>
           </a:bodyPr>
           <a:lstStyle/>
@@ -3461,10 +3448,16 @@
                 <a:solidFill>
                   <a:srgbClr val="1F3A5F"/>
                 </a:solidFill>
-                <a:latin typeface="Trebuchet MS"/>
+                <a:latin typeface="Trebuchet MS" panose="020B0603020202020204"/>
               </a:rPr>
               <a:t>0.76</a:t>
             </a:r>
+            <a:endParaRPr sz="3400" b="1" i="0">
+              <a:solidFill>
+                <a:srgbClr val="1F3A5F"/>
+              </a:solidFill>
+              <a:latin typeface="Trebuchet MS" panose="020B0603020202020204"/>
+            </a:endParaRPr>
           </a:p>
           <a:p>
             <a:pPr algn="ctr">
@@ -3477,10 +3470,16 @@
                 <a:solidFill>
                   <a:srgbClr val="222B35"/>
                 </a:solidFill>
-                <a:latin typeface="Calibri"/>
+                <a:latin typeface="Calibri" panose="020F0502020204030204"/>
               </a:rPr>
               <a:t>frozen DINOv2-small,</a:t>
             </a:r>
+            <a:endParaRPr sz="1400" b="0" i="0">
+              <a:solidFill>
+                <a:srgbClr val="222B35"/>
+              </a:solidFill>
+              <a:latin typeface="Calibri" panose="020F0502020204030204"/>
+            </a:endParaRPr>
           </a:p>
           <a:p>
             <a:pPr algn="ctr">
@@ -3493,10 +3492,16 @@
                 <a:solidFill>
                   <a:srgbClr val="222B35"/>
                 </a:solidFill>
-                <a:latin typeface="Calibri"/>
+                <a:latin typeface="Calibri" panose="020F0502020204030204"/>
               </a:rPr>
               <a:t>fully reproducible</a:t>
             </a:r>
+            <a:endParaRPr sz="1400" b="0" i="0">
+              <a:solidFill>
+                <a:srgbClr val="222B35"/>
+              </a:solidFill>
+              <a:latin typeface="Calibri" panose="020F0502020204030204"/>
+            </a:endParaRPr>
           </a:p>
         </p:txBody>
       </p:sp>
@@ -3605,7 +3610,7 @@
           <a:noFill/>
         </p:spPr>
         <p:txBody>
-          <a:bodyPr wrap="square" lIns="45720" rIns="45720" tIns="27432" bIns="27432">
+          <a:bodyPr wrap="square" lIns="45720" tIns="27432" rIns="45720" bIns="27432">
             <a:spAutoFit/>
           </a:bodyPr>
           <a:lstStyle/>
@@ -3620,10 +3625,16 @@
                 <a:solidFill>
                   <a:srgbClr val="FFFFFF"/>
                 </a:solidFill>
-                <a:latin typeface="Trebuchet MS"/>
+                <a:latin typeface="Trebuchet MS" panose="020B0603020202020204"/>
               </a:rPr>
               <a:t>Ours + padding/base</a:t>
             </a:r>
+            <a:endParaRPr sz="1600" b="1" i="0">
+              <a:solidFill>
+                <a:srgbClr val="FFFFFF"/>
+              </a:solidFill>
+              <a:latin typeface="Trebuchet MS" panose="020B0603020202020204"/>
+            </a:endParaRPr>
           </a:p>
         </p:txBody>
       </p:sp>
@@ -3644,7 +3655,7 @@
           <a:noFill/>
         </p:spPr>
         <p:txBody>
-          <a:bodyPr wrap="square" lIns="45720" rIns="45720" tIns="27432" bIns="27432">
+          <a:bodyPr wrap="square" lIns="45720" tIns="27432" rIns="45720" bIns="27432">
             <a:spAutoFit/>
           </a:bodyPr>
           <a:lstStyle/>
@@ -3659,10 +3670,16 @@
                 <a:solidFill>
                   <a:srgbClr val="1AB3A3"/>
                 </a:solidFill>
-                <a:latin typeface="Trebuchet MS"/>
+                <a:latin typeface="Trebuchet MS" panose="020B0603020202020204"/>
               </a:rPr>
               <a:t>~0.83–0.90</a:t>
             </a:r>
+            <a:endParaRPr sz="3400" b="1" i="0">
+              <a:solidFill>
+                <a:srgbClr val="1AB3A3"/>
+              </a:solidFill>
+              <a:latin typeface="Trebuchet MS" panose="020B0603020202020204"/>
+            </a:endParaRPr>
           </a:p>
           <a:p>
             <a:pPr algn="ctr">
@@ -3675,10 +3692,16 @@
                 <a:solidFill>
                   <a:srgbClr val="222B35"/>
                 </a:solidFill>
-                <a:latin typeface="Calibri"/>
+                <a:latin typeface="Calibri" panose="020F0502020204030204"/>
               </a:rPr>
               <a:t>mask padding, DINOv2-base,</a:t>
             </a:r>
+            <a:endParaRPr sz="1400" b="0" i="0">
+              <a:solidFill>
+                <a:srgbClr val="222B35"/>
+              </a:solidFill>
+              <a:latin typeface="Calibri" panose="020F0502020204030204"/>
+            </a:endParaRPr>
           </a:p>
           <a:p>
             <a:pPr algn="ctr">
@@ -3691,10 +3714,16 @@
                 <a:solidFill>
                   <a:srgbClr val="222B35"/>
                 </a:solidFill>
-                <a:latin typeface="Calibri"/>
+                <a:latin typeface="Calibri" panose="020F0502020204030204"/>
               </a:rPr>
               <a:t>multi-seed</a:t>
             </a:r>
+            <a:endParaRPr sz="1400" b="0" i="0">
+              <a:solidFill>
+                <a:srgbClr val="222B35"/>
+              </a:solidFill>
+              <a:latin typeface="Calibri" panose="020F0502020204030204"/>
+            </a:endParaRPr>
           </a:p>
         </p:txBody>
       </p:sp>
@@ -3803,7 +3832,7 @@
           <a:noFill/>
         </p:spPr>
         <p:txBody>
-          <a:bodyPr wrap="square" lIns="45720" rIns="45720" tIns="27432" bIns="27432">
+          <a:bodyPr wrap="square" lIns="45720" tIns="27432" rIns="45720" bIns="27432">
             <a:spAutoFit/>
           </a:bodyPr>
           <a:lstStyle/>
@@ -3818,10 +3847,16 @@
                 <a:solidFill>
                   <a:srgbClr val="FFFFFF"/>
                 </a:solidFill>
-                <a:latin typeface="Trebuchet MS"/>
+                <a:latin typeface="Trebuchet MS" panose="020B0603020202020204"/>
               </a:rPr>
               <a:t>SOTA (CSAD/SALAD)</a:t>
             </a:r>
+            <a:endParaRPr sz="1600" b="1" i="0">
+              <a:solidFill>
+                <a:srgbClr val="FFFFFF"/>
+              </a:solidFill>
+              <a:latin typeface="Trebuchet MS" panose="020B0603020202020204"/>
+            </a:endParaRPr>
           </a:p>
         </p:txBody>
       </p:sp>
@@ -3842,7 +3877,7 @@
           <a:noFill/>
         </p:spPr>
         <p:txBody>
-          <a:bodyPr wrap="square" lIns="45720" rIns="45720" tIns="27432" bIns="27432">
+          <a:bodyPr wrap="square" lIns="45720" tIns="27432" rIns="45720" bIns="27432">
             <a:spAutoFit/>
           </a:bodyPr>
           <a:lstStyle/>
@@ -3857,10 +3892,16 @@
                 <a:solidFill>
                   <a:srgbClr val="5A6774"/>
                 </a:solidFill>
-                <a:latin typeface="Trebuchet MS"/>
+                <a:latin typeface="Trebuchet MS" panose="020B0603020202020204"/>
               </a:rPr>
               <a:t>0.95–0.96</a:t>
             </a:r>
+            <a:endParaRPr sz="3400" b="1" i="0">
+              <a:solidFill>
+                <a:srgbClr val="5A6774"/>
+              </a:solidFill>
+              <a:latin typeface="Trebuchet MS" panose="020B0603020202020204"/>
+            </a:endParaRPr>
           </a:p>
           <a:p>
             <a:pPr algn="ctr">
@@ -3873,10 +3914,16 @@
                 <a:solidFill>
                   <a:srgbClr val="222B35"/>
                 </a:solidFill>
-                <a:latin typeface="Calibri"/>
+                <a:latin typeface="Calibri" panose="020F0502020204030204"/>
               </a:rPr>
               <a:t>component segmentation,</a:t>
             </a:r>
+            <a:endParaRPr sz="1400" b="0" i="0">
+              <a:solidFill>
+                <a:srgbClr val="222B35"/>
+              </a:solidFill>
+              <a:latin typeface="Calibri" panose="020F0502020204030204"/>
+            </a:endParaRPr>
           </a:p>
           <a:p>
             <a:pPr algn="ctr">
@@ -3889,10 +3936,16 @@
                 <a:solidFill>
                   <a:srgbClr val="222B35"/>
                 </a:solidFill>
-                <a:latin typeface="Calibri"/>
+                <a:latin typeface="Calibri" panose="020F0502020204030204"/>
               </a:rPr>
               <a:t>heavy training</a:t>
             </a:r>
+            <a:endParaRPr sz="1400" b="0" i="0">
+              <a:solidFill>
+                <a:srgbClr val="222B35"/>
+              </a:solidFill>
+              <a:latin typeface="Calibri" panose="020F0502020204030204"/>
+            </a:endParaRPr>
           </a:p>
         </p:txBody>
       </p:sp>
@@ -3913,7 +3966,7 @@
           <a:noFill/>
         </p:spPr>
         <p:txBody>
-          <a:bodyPr wrap="square" lIns="45720" rIns="45720" tIns="27432" bIns="27432">
+          <a:bodyPr wrap="square" lIns="45720" tIns="27432" rIns="45720" bIns="27432">
             <a:spAutoFit/>
           </a:bodyPr>
           <a:lstStyle/>
@@ -3928,10 +3981,16 @@
                 <a:solidFill>
                   <a:srgbClr val="1F3A5F"/>
                 </a:solidFill>
-                <a:latin typeface="Trebuchet MS"/>
+                <a:latin typeface="Trebuchet MS" panose="020B0603020202020204"/>
               </a:rPr>
               <a:t>Our contribution is rigor, reproducibility, and explainability — not chasing a leaderboard number.</a:t>
             </a:r>
+            <a:endParaRPr sz="1800" b="1" i="0">
+              <a:solidFill>
+                <a:srgbClr val="1F3A5F"/>
+              </a:solidFill>
+              <a:latin typeface="Trebuchet MS" panose="020B0603020202020204"/>
+            </a:endParaRPr>
           </a:p>
           <a:p>
             <a:pPr algn="l">
@@ -3944,10 +4003,16 @@
                 <a:solidFill>
                   <a:srgbClr val="222B35"/>
                 </a:solidFill>
-                <a:latin typeface="Calibri"/>
+                <a:latin typeface="Calibri" panose="020F0502020204030204"/>
               </a:rPr>
               <a:t>We name each method for what it actually computes, keep evaluation leakage-free, and audit the data end to end. Features are verified as real DINOv2; the remaining gap is padding-masking, a larger backbone, and multi-seed — not a redesign.</a:t>
             </a:r>
+            <a:endParaRPr sz="1500" b="0" i="0">
+              <a:solidFill>
+                <a:srgbClr val="222B35"/>
+              </a:solidFill>
+              <a:latin typeface="Calibri" panose="020F0502020204030204"/>
+            </a:endParaRPr>
           </a:p>
         </p:txBody>
       </p:sp>
@@ -3960,7 +4025,7 @@
 </file>
 
 <file path=ppt/slides/slide11.xml><?xml version="1.0" encoding="utf-8"?>
-<p:sld xmlns:a="http://schemas.openxmlformats.org/drawingml/2006/main" xmlns:p="http://schemas.openxmlformats.org/presentationml/2006/main" xmlns:r="http://schemas.openxmlformats.org/officeDocument/2006/relationships">
+<p:sld xmlns:a="http://schemas.openxmlformats.org/drawingml/2006/main" xmlns:r="http://schemas.openxmlformats.org/officeDocument/2006/relationships" xmlns:p="http://schemas.openxmlformats.org/presentationml/2006/main">
   <p:cSld>
     <p:bg>
       <p:bgPr>
@@ -4038,7 +4103,7 @@
           <a:noFill/>
         </p:spPr>
         <p:txBody>
-          <a:bodyPr wrap="square" lIns="45720" rIns="45720" tIns="27432" bIns="27432">
+          <a:bodyPr wrap="square" lIns="45720" tIns="27432" rIns="45720" bIns="27432">
             <a:spAutoFit/>
           </a:bodyPr>
           <a:lstStyle/>
@@ -4053,10 +4118,16 @@
                 <a:solidFill>
                   <a:srgbClr val="FFFFFF"/>
                 </a:solidFill>
-                <a:latin typeface="Trebuchet MS"/>
+                <a:latin typeface="Trebuchet MS" panose="020B0603020202020204"/>
               </a:rPr>
               <a:t>Summary &amp; next steps</a:t>
             </a:r>
+            <a:endParaRPr sz="3000" b="1" i="0">
+              <a:solidFill>
+                <a:srgbClr val="FFFFFF"/>
+              </a:solidFill>
+              <a:latin typeface="Trebuchet MS" panose="020B0603020202020204"/>
+            </a:endParaRPr>
           </a:p>
         </p:txBody>
       </p:sp>
@@ -4077,7 +4148,7 @@
           <a:noFill/>
         </p:spPr>
         <p:txBody>
-          <a:bodyPr wrap="square" lIns="45720" rIns="45720" tIns="27432" bIns="27432">
+          <a:bodyPr wrap="square" lIns="45720" tIns="27432" rIns="45720" bIns="27432">
             <a:spAutoFit/>
           </a:bodyPr>
           <a:lstStyle/>
@@ -4093,10 +4164,16 @@
                 <a:solidFill>
                   <a:srgbClr val="FFFFFF"/>
                 </a:solidFill>
-                <a:latin typeface="Calibri"/>
+                <a:latin typeface="Calibri" panose="020F0502020204030204"/>
               </a:rPr>
               <a:t>A complete, working product: reproducible pipeline, four detectors + fusion, and an offline explainable dashboard.</a:t>
             </a:r>
+            <a:endParaRPr sz="1800" b="0" i="0">
+              <a:solidFill>
+                <a:srgbClr val="FFFFFF"/>
+              </a:solidFill>
+              <a:latin typeface="Calibri" panose="020F0502020204030204"/>
+            </a:endParaRPr>
           </a:p>
           <a:p>
             <a:pPr algn="l">
@@ -4110,10 +4187,16 @@
                 <a:solidFill>
                   <a:srgbClr val="FFFFFF"/>
                 </a:solidFill>
-                <a:latin typeface="Calibri"/>
+                <a:latin typeface="Calibri" panose="020F0502020204030204"/>
               </a:rPr>
               <a:t>Best fusion: 0.76 overall AUROC (0.73 logical / 0.80 structural) on real DINOv2 features — a transparent, defensible result.</a:t>
             </a:r>
+            <a:endParaRPr sz="1800" b="0" i="0">
+              <a:solidFill>
+                <a:srgbClr val="FFFFFF"/>
+              </a:solidFill>
+              <a:latin typeface="Calibri" panose="020F0502020204030204"/>
+            </a:endParaRPr>
           </a:p>
           <a:p>
             <a:pPr algn="l">
@@ -4127,10 +4210,16 @@
                 <a:solidFill>
                   <a:srgbClr val="FFFFFF"/>
                 </a:solidFill>
-                <a:latin typeface="Calibri"/>
+                <a:latin typeface="Calibri" panose="020F0502020204030204"/>
               </a:rPr>
               <a:t>Feature selection (drop redundant + harmful branches) gives a leaner, better model (0.764).</a:t>
             </a:r>
+            <a:endParaRPr sz="1800" b="0" i="0">
+              <a:solidFill>
+                <a:srgbClr val="FFFFFF"/>
+              </a:solidFill>
+              <a:latin typeface="Calibri" panose="020F0502020204030204"/>
+            </a:endParaRPr>
           </a:p>
           <a:p>
             <a:pPr algn="l">
@@ -4144,10 +4233,16 @@
                 <a:solidFill>
                   <a:srgbClr val="1AB3A3"/>
                 </a:solidFill>
-                <a:latin typeface="Calibri"/>
+                <a:latin typeface="Calibri" panose="020F0502020204030204"/>
               </a:rPr>
               <a:t>Next: mask letterbox padding, move to DINOv2-base, add the official sPRO metric, and report multi-seed confidence intervals.</a:t>
             </a:r>
+            <a:endParaRPr sz="1800" b="1" i="0">
+              <a:solidFill>
+                <a:srgbClr val="1AB3A3"/>
+              </a:solidFill>
+              <a:latin typeface="Calibri" panose="020F0502020204030204"/>
+            </a:endParaRPr>
           </a:p>
         </p:txBody>
       </p:sp>
@@ -4168,7 +4263,7 @@
           <a:noFill/>
         </p:spPr>
         <p:txBody>
-          <a:bodyPr wrap="square" lIns="45720" rIns="45720" tIns="27432" bIns="27432">
+          <a:bodyPr wrap="square" lIns="45720" tIns="27432" rIns="45720" bIns="27432">
             <a:spAutoFit/>
           </a:bodyPr>
           <a:lstStyle/>
@@ -4183,10 +4278,16 @@
                 <a:solidFill>
                   <a:srgbClr val="CADCFC"/>
                 </a:solidFill>
-                <a:latin typeface="Calibri"/>
+                <a:latin typeface="Calibri" panose="020F0502020204030204"/>
               </a:rPr>
               <a:t>Thank you — live demo: open dashboard.html</a:t>
             </a:r>
+            <a:endParaRPr sz="1600" b="0" i="1">
+              <a:solidFill>
+                <a:srgbClr val="CADCFC"/>
+              </a:solidFill>
+              <a:latin typeface="Calibri" panose="020F0502020204030204"/>
+            </a:endParaRPr>
           </a:p>
         </p:txBody>
       </p:sp>
@@ -4199,7 +4300,7 @@
 </file>
 
 <file path=ppt/slides/slide2.xml><?xml version="1.0" encoding="utf-8"?>
-<p:sld xmlns:a="http://schemas.openxmlformats.org/drawingml/2006/main" xmlns:p="http://schemas.openxmlformats.org/presentationml/2006/main" xmlns:r="http://schemas.openxmlformats.org/officeDocument/2006/relationships">
+<p:sld xmlns:a="http://schemas.openxmlformats.org/drawingml/2006/main" xmlns:r="http://schemas.openxmlformats.org/officeDocument/2006/relationships" xmlns:p="http://schemas.openxmlformats.org/presentationml/2006/main">
   <p:cSld>
     <p:bg>
       <p:bgPr>
@@ -4225,7 +4326,7 @@
         <p:spPr>
           <a:xfrm>
             <a:off x="548640" y="384048"/>
-            <a:ext cx="11064240" cy="914400"/>
+            <a:ext cx="11064240" cy="516255"/>
           </a:xfrm>
           <a:prstGeom prst="rect">
             <a:avLst/>
@@ -4233,7 +4334,7 @@
           <a:noFill/>
         </p:spPr>
         <p:txBody>
-          <a:bodyPr wrap="square" lIns="45720" rIns="45720" tIns="27432" bIns="27432">
+          <a:bodyPr wrap="square" lIns="45720" tIns="27432" rIns="45720" bIns="27432">
             <a:spAutoFit/>
           </a:bodyPr>
           <a:lstStyle/>
@@ -4248,10 +4349,16 @@
                 <a:solidFill>
                   <a:srgbClr val="1F3A5F"/>
                 </a:solidFill>
-                <a:latin typeface="Trebuchet MS"/>
-              </a:rPr>
-              <a:t>Two kinds of defect — one is much harder</a:t>
-            </a:r>
+                <a:latin typeface="Trebuchet MS" panose="020B0603020202020204"/>
+              </a:rPr>
+              <a:t>Two kinds of defect </a:t>
+            </a:r>
+            <a:endParaRPr sz="3000" b="1" i="0">
+              <a:solidFill>
+                <a:srgbClr val="1F3A5F"/>
+              </a:solidFill>
+              <a:latin typeface="Trebuchet MS" panose="020B0603020202020204"/>
+            </a:endParaRPr>
           </a:p>
         </p:txBody>
       </p:sp>
@@ -4272,7 +4379,7 @@
           <a:noFill/>
         </p:spPr>
         <p:txBody>
-          <a:bodyPr wrap="square" lIns="45720" rIns="45720" tIns="27432" bIns="27432">
+          <a:bodyPr wrap="square" lIns="45720" tIns="27432" rIns="45720" bIns="27432">
             <a:spAutoFit/>
           </a:bodyPr>
           <a:lstStyle/>
@@ -4287,10 +4394,16 @@
                 <a:solidFill>
                   <a:srgbClr val="1F3A5F"/>
                 </a:solidFill>
-                <a:latin typeface="Trebuchet MS"/>
+                <a:latin typeface="Trebuchet MS" panose="020B0603020202020204"/>
               </a:rPr>
               <a:t>Structural anomalies</a:t>
             </a:r>
+            <a:endParaRPr sz="1900" b="1" i="0">
+              <a:solidFill>
+                <a:srgbClr val="1F3A5F"/>
+              </a:solidFill>
+              <a:latin typeface="Trebuchet MS" panose="020B0603020202020204"/>
+            </a:endParaRPr>
           </a:p>
           <a:p>
             <a:pPr algn="l">
@@ -4303,10 +4416,16 @@
                 <a:solidFill>
                   <a:srgbClr val="222B35"/>
                 </a:solidFill>
-                <a:latin typeface="Calibri"/>
+                <a:latin typeface="Calibri" panose="020F0502020204030204"/>
               </a:rPr>
               <a:t>Local appearance defects — scratches, dents, cracks. Visible in a small region.</a:t>
             </a:r>
+            <a:endParaRPr sz="1500" b="0" i="0">
+              <a:solidFill>
+                <a:srgbClr val="222B35"/>
+              </a:solidFill>
+              <a:latin typeface="Calibri" panose="020F0502020204030204"/>
+            </a:endParaRPr>
           </a:p>
           <a:p>
             <a:pPr algn="l">
@@ -4319,10 +4438,16 @@
                 <a:solidFill>
                   <a:srgbClr val="1F3A5F"/>
                 </a:solidFill>
-                <a:latin typeface="Trebuchet MS"/>
+                <a:latin typeface="Trebuchet MS" panose="020B0603020202020204"/>
               </a:rPr>
               <a:t>Logical anomalies</a:t>
             </a:r>
+            <a:endParaRPr sz="1900" b="1" i="0">
+              <a:solidFill>
+                <a:srgbClr val="1F3A5F"/>
+              </a:solidFill>
+              <a:latin typeface="Trebuchet MS" panose="020B0603020202020204"/>
+            </a:endParaRPr>
           </a:p>
           <a:p>
             <a:pPr algn="l">
@@ -4335,10 +4460,16 @@
                 <a:solidFill>
                   <a:srgbClr val="222B35"/>
                 </a:solidFill>
-                <a:latin typeface="Calibri"/>
+                <a:latin typeface="Calibri" panose="020F0502020204030204"/>
               </a:rPr>
               <a:t>Global rule violations — a missing fruit, an extra pushpin, a swapped part. Every region looks normal; only the overall composition is wrong.</a:t>
             </a:r>
+            <a:endParaRPr sz="1500" b="0" i="0">
+              <a:solidFill>
+                <a:srgbClr val="222B35"/>
+              </a:solidFill>
+              <a:latin typeface="Calibri" panose="020F0502020204030204"/>
+            </a:endParaRPr>
           </a:p>
           <a:p>
             <a:pPr algn="l">
@@ -4351,10 +4482,16 @@
                 <a:solidFill>
                   <a:srgbClr val="1AB3A3"/>
                 </a:solidFill>
-                <a:latin typeface="Calibri"/>
+                <a:latin typeface="Calibri" panose="020F0502020204030204"/>
               </a:rPr>
               <a:t>Trained only on defect-free images — no labelled defects.</a:t>
             </a:r>
+            <a:endParaRPr sz="1500" b="1" i="1">
+              <a:solidFill>
+                <a:srgbClr val="1AB3A3"/>
+              </a:solidFill>
+              <a:latin typeface="Calibri" panose="020F0502020204030204"/>
+            </a:endParaRPr>
           </a:p>
         </p:txBody>
       </p:sp>
@@ -4367,7 +4504,7 @@
           <p:nvPr/>
         </p:nvPicPr>
         <p:blipFill>
-          <a:blip r:embed="rId2"/>
+          <a:blip r:embed="rId1"/>
           <a:stretch>
             <a:fillRect/>
           </a:stretch>
@@ -4391,7 +4528,7 @@
 </file>
 
 <file path=ppt/slides/slide3.xml><?xml version="1.0" encoding="utf-8"?>
-<p:sld xmlns:a="http://schemas.openxmlformats.org/drawingml/2006/main" xmlns:p="http://schemas.openxmlformats.org/presentationml/2006/main" xmlns:r="http://schemas.openxmlformats.org/officeDocument/2006/relationships">
+<p:sld xmlns:a="http://schemas.openxmlformats.org/drawingml/2006/main" xmlns:r="http://schemas.openxmlformats.org/officeDocument/2006/relationships" xmlns:p="http://schemas.openxmlformats.org/presentationml/2006/main">
   <p:cSld>
     <p:bg>
       <p:bgPr>
@@ -4425,7 +4562,7 @@
           <a:noFill/>
         </p:spPr>
         <p:txBody>
-          <a:bodyPr wrap="square" lIns="45720" rIns="45720" tIns="27432" bIns="27432">
+          <a:bodyPr wrap="square" lIns="45720" tIns="27432" rIns="45720" bIns="27432">
             <a:spAutoFit/>
           </a:bodyPr>
           <a:lstStyle/>
@@ -4440,10 +4577,16 @@
                 <a:solidFill>
                   <a:srgbClr val="1F3A5F"/>
                 </a:solidFill>
-                <a:latin typeface="Trebuchet MS"/>
+                <a:latin typeface="Trebuchet MS" panose="020B0603020202020204"/>
               </a:rPr>
               <a:t>What we built — and why</a:t>
             </a:r>
+            <a:endParaRPr sz="3000" b="1" i="0">
+              <a:solidFill>
+                <a:srgbClr val="1F3A5F"/>
+              </a:solidFill>
+              <a:latin typeface="Trebuchet MS" panose="020B0603020202020204"/>
+            </a:endParaRPr>
           </a:p>
         </p:txBody>
       </p:sp>
@@ -4464,7 +4607,7 @@
           <a:noFill/>
         </p:spPr>
         <p:txBody>
-          <a:bodyPr wrap="square" lIns="45720" rIns="45720" tIns="27432" bIns="27432">
+          <a:bodyPr wrap="square" lIns="45720" tIns="27432" rIns="45720" bIns="27432">
             <a:spAutoFit/>
           </a:bodyPr>
           <a:lstStyle/>
@@ -4479,10 +4622,16 @@
                 <a:solidFill>
                   <a:srgbClr val="5A6774"/>
                 </a:solidFill>
-                <a:latin typeface="Calibri"/>
+                <a:latin typeface="Calibri" panose="020F0502020204030204"/>
               </a:rPr>
               <a:t>A self-contained dashboard + reproducible ML pipeline that detects and explains anomalies in industrial product images.</a:t>
             </a:r>
+            <a:endParaRPr sz="1600" b="0" i="1">
+              <a:solidFill>
+                <a:srgbClr val="5A6774"/>
+              </a:solidFill>
+              <a:latin typeface="Calibri" panose="020F0502020204030204"/>
+            </a:endParaRPr>
           </a:p>
         </p:txBody>
       </p:sp>
@@ -4547,7 +4696,7 @@
           <a:noFill/>
         </p:spPr>
         <p:txBody>
-          <a:bodyPr wrap="square" lIns="45720" rIns="45720" tIns="27432" bIns="27432">
+          <a:bodyPr wrap="square" lIns="45720" tIns="27432" rIns="45720" bIns="27432">
             <a:spAutoFit/>
           </a:bodyPr>
           <a:lstStyle/>
@@ -4562,10 +4711,16 @@
                 <a:solidFill>
                   <a:srgbClr val="1F3A5F"/>
                 </a:solidFill>
-                <a:latin typeface="Trebuchet MS"/>
+                <a:latin typeface="Trebuchet MS" panose="020B0603020202020204"/>
               </a:rPr>
               <a:t>Detect both types</a:t>
             </a:r>
+            <a:endParaRPr sz="1800" b="1" i="0">
+              <a:solidFill>
+                <a:srgbClr val="1F3A5F"/>
+              </a:solidFill>
+              <a:latin typeface="Trebuchet MS" panose="020B0603020202020204"/>
+            </a:endParaRPr>
           </a:p>
           <a:p>
             <a:pPr algn="l">
@@ -4578,10 +4733,16 @@
                 <a:solidFill>
                   <a:srgbClr val="222B35"/>
                 </a:solidFill>
-                <a:latin typeface="Calibri"/>
+                <a:latin typeface="Calibri" panose="020F0502020204030204"/>
               </a:rPr>
               <a:t>Flag logical and structural defects from good images only.</a:t>
             </a:r>
+            <a:endParaRPr sz="1450" b="0" i="0">
+              <a:solidFill>
+                <a:srgbClr val="222B35"/>
+              </a:solidFill>
+              <a:latin typeface="Calibri" panose="020F0502020204030204"/>
+            </a:endParaRPr>
           </a:p>
         </p:txBody>
       </p:sp>
@@ -4646,7 +4807,7 @@
           <a:noFill/>
         </p:spPr>
         <p:txBody>
-          <a:bodyPr wrap="square" lIns="45720" rIns="45720" tIns="27432" bIns="27432">
+          <a:bodyPr wrap="square" lIns="45720" tIns="27432" rIns="45720" bIns="27432">
             <a:spAutoFit/>
           </a:bodyPr>
           <a:lstStyle/>
@@ -4661,10 +4822,16 @@
                 <a:solidFill>
                   <a:srgbClr val="1F3A5F"/>
                 </a:solidFill>
-                <a:latin typeface="Trebuchet MS"/>
+                <a:latin typeface="Trebuchet MS" panose="020B0603020202020204"/>
               </a:rPr>
               <a:t>Explain every decision</a:t>
             </a:r>
+            <a:endParaRPr sz="1800" b="1" i="0">
+              <a:solidFill>
+                <a:srgbClr val="1F3A5F"/>
+              </a:solidFill>
+              <a:latin typeface="Trebuchet MS" panose="020B0603020202020204"/>
+            </a:endParaRPr>
           </a:p>
           <a:p>
             <a:pPr algn="l">
@@ -4677,10 +4844,16 @@
                 <a:solidFill>
                   <a:srgbClr val="222B35"/>
                 </a:solidFill>
-                <a:latin typeface="Calibri"/>
+                <a:latin typeface="Calibri" panose="020F0502020204030204"/>
               </a:rPr>
               <a:t>Show the anomaly score, the threshold, and where the defect is.</a:t>
             </a:r>
+            <a:endParaRPr sz="1450" b="0" i="0">
+              <a:solidFill>
+                <a:srgbClr val="222B35"/>
+              </a:solidFill>
+              <a:latin typeface="Calibri" panose="020F0502020204030204"/>
+            </a:endParaRPr>
           </a:p>
         </p:txBody>
       </p:sp>
@@ -4745,7 +4918,7 @@
           <a:noFill/>
         </p:spPr>
         <p:txBody>
-          <a:bodyPr wrap="square" lIns="45720" rIns="45720" tIns="27432" bIns="27432">
+          <a:bodyPr wrap="square" lIns="45720" tIns="27432" rIns="45720" bIns="27432">
             <a:spAutoFit/>
           </a:bodyPr>
           <a:lstStyle/>
@@ -4760,10 +4933,16 @@
                 <a:solidFill>
                   <a:srgbClr val="1F3A5F"/>
                 </a:solidFill>
-                <a:latin typeface="Trebuchet MS"/>
+                <a:latin typeface="Trebuchet MS" panose="020B0603020202020204"/>
               </a:rPr>
               <a:t>Relevant analysis only</a:t>
             </a:r>
+            <a:endParaRPr sz="1800" b="1" i="0">
+              <a:solidFill>
+                <a:srgbClr val="1F3A5F"/>
+              </a:solidFill>
+              <a:latin typeface="Trebuchet MS" panose="020B0603020202020204"/>
+            </a:endParaRPr>
           </a:p>
           <a:p>
             <a:pPr algn="l">
@@ -4776,10 +4955,16 @@
                 <a:solidFill>
                   <a:srgbClr val="222B35"/>
                 </a:solidFill>
-                <a:latin typeface="Calibri"/>
+                <a:latin typeface="Calibri" panose="020F0502020204030204"/>
               </a:rPr>
               <a:t>Surface the EDA that informs the model — not decorative charts.</a:t>
             </a:r>
+            <a:endParaRPr sz="1450" b="0" i="0">
+              <a:solidFill>
+                <a:srgbClr val="222B35"/>
+              </a:solidFill>
+              <a:latin typeface="Calibri" panose="020F0502020204030204"/>
+            </a:endParaRPr>
           </a:p>
         </p:txBody>
       </p:sp>
@@ -4844,7 +5029,7 @@
           <a:noFill/>
         </p:spPr>
         <p:txBody>
-          <a:bodyPr wrap="square" lIns="45720" rIns="45720" tIns="27432" bIns="27432">
+          <a:bodyPr wrap="square" lIns="45720" tIns="27432" rIns="45720" bIns="27432">
             <a:spAutoFit/>
           </a:bodyPr>
           <a:lstStyle/>
@@ -4859,10 +5044,16 @@
                 <a:solidFill>
                   <a:srgbClr val="1F3A5F"/>
                 </a:solidFill>
-                <a:latin typeface="Trebuchet MS"/>
+                <a:latin typeface="Trebuchet MS" panose="020B0603020202020204"/>
               </a:rPr>
               <a:t>Fully reproducible</a:t>
             </a:r>
+            <a:endParaRPr sz="1800" b="1" i="0">
+              <a:solidFill>
+                <a:srgbClr val="1F3A5F"/>
+              </a:solidFill>
+              <a:latin typeface="Trebuchet MS" panose="020B0603020202020204"/>
+            </a:endParaRPr>
           </a:p>
           <a:p>
             <a:pPr algn="l">
@@ -4875,10 +5066,16 @@
                 <a:solidFill>
                   <a:srgbClr val="222B35"/>
                 </a:solidFill>
-                <a:latin typeface="Calibri"/>
+                <a:latin typeface="Calibri" panose="020F0502020204030204"/>
               </a:rPr>
               <a:t>Fixed seeds, leakage-checked data, saved configs — every result is auditable.</a:t>
             </a:r>
+            <a:endParaRPr sz="1450" b="0" i="0">
+              <a:solidFill>
+                <a:srgbClr val="222B35"/>
+              </a:solidFill>
+              <a:latin typeface="Calibri" panose="020F0502020204030204"/>
+            </a:endParaRPr>
           </a:p>
         </p:txBody>
       </p:sp>
@@ -4891,7 +5088,7 @@
 </file>
 
 <file path=ppt/slides/slide4.xml><?xml version="1.0" encoding="utf-8"?>
-<p:sld xmlns:a="http://schemas.openxmlformats.org/drawingml/2006/main" xmlns:p="http://schemas.openxmlformats.org/presentationml/2006/main" xmlns:r="http://schemas.openxmlformats.org/officeDocument/2006/relationships">
+<p:sld xmlns:a="http://schemas.openxmlformats.org/drawingml/2006/main" xmlns:r="http://schemas.openxmlformats.org/officeDocument/2006/relationships" xmlns:p="http://schemas.openxmlformats.org/presentationml/2006/main">
   <p:cSld>
     <p:bg>
       <p:bgPr>
@@ -4925,7 +5122,7 @@
           <a:noFill/>
         </p:spPr>
         <p:txBody>
-          <a:bodyPr wrap="square" lIns="45720" rIns="45720" tIns="27432" bIns="27432">
+          <a:bodyPr wrap="square" lIns="45720" tIns="27432" rIns="45720" bIns="27432">
             <a:spAutoFit/>
           </a:bodyPr>
           <a:lstStyle/>
@@ -4940,10 +5137,16 @@
                 <a:solidFill>
                   <a:srgbClr val="1F3A5F"/>
                 </a:solidFill>
-                <a:latin typeface="Trebuchet MS"/>
+                <a:latin typeface="Trebuchet MS" panose="020B0603020202020204"/>
               </a:rPr>
               <a:t>How it works — end to end</a:t>
             </a:r>
+            <a:endParaRPr sz="3000" b="1" i="0">
+              <a:solidFill>
+                <a:srgbClr val="1F3A5F"/>
+              </a:solidFill>
+              <a:latin typeface="Trebuchet MS" panose="020B0603020202020204"/>
+            </a:endParaRPr>
           </a:p>
         </p:txBody>
       </p:sp>
@@ -4956,7 +5159,7 @@
           <p:nvPr/>
         </p:nvPicPr>
         <p:blipFill>
-          <a:blip r:embed="rId2"/>
+          <a:blip r:embed="rId1"/>
           <a:stretch>
             <a:fillRect/>
           </a:stretch>
@@ -4988,7 +5191,7 @@
           <a:noFill/>
         </p:spPr>
         <p:txBody>
-          <a:bodyPr wrap="square" lIns="45720" rIns="45720" tIns="27432" bIns="27432">
+          <a:bodyPr wrap="square" lIns="45720" tIns="27432" rIns="45720" bIns="27432">
             <a:spAutoFit/>
           </a:bodyPr>
           <a:lstStyle/>
@@ -5003,10 +5206,16 @@
                 <a:solidFill>
                   <a:srgbClr val="5A6774"/>
                 </a:solidFill>
-                <a:latin typeface="Calibri"/>
+                <a:latin typeface="Calibri" panose="020F0502020204030204"/>
               </a:rPr>
               <a:t>Data audit &amp; letterbox preprocessing → EDA → four detectors → validation-only fusion → evaluation → dashboard &amp; report. All logic in one shared module.</a:t>
             </a:r>
+            <a:endParaRPr sz="1400" b="0" i="1">
+              <a:solidFill>
+                <a:srgbClr val="5A6774"/>
+              </a:solidFill>
+              <a:latin typeface="Calibri" panose="020F0502020204030204"/>
+            </a:endParaRPr>
           </a:p>
         </p:txBody>
       </p:sp>
@@ -5019,7 +5228,7 @@
 </file>
 
 <file path=ppt/slides/slide5.xml><?xml version="1.0" encoding="utf-8"?>
-<p:sld xmlns:a="http://schemas.openxmlformats.org/drawingml/2006/main" xmlns:p="http://schemas.openxmlformats.org/presentationml/2006/main" xmlns:r="http://schemas.openxmlformats.org/officeDocument/2006/relationships">
+<p:sld xmlns:a="http://schemas.openxmlformats.org/drawingml/2006/main" xmlns:r="http://schemas.openxmlformats.org/officeDocument/2006/relationships" xmlns:p="http://schemas.openxmlformats.org/presentationml/2006/main">
   <p:cSld>
     <p:bg>
       <p:bgPr>
@@ -5053,7 +5262,7 @@
           <a:noFill/>
         </p:spPr>
         <p:txBody>
-          <a:bodyPr wrap="square" lIns="45720" rIns="45720" tIns="27432" bIns="27432">
+          <a:bodyPr wrap="square" lIns="45720" tIns="27432" rIns="45720" bIns="27432">
             <a:spAutoFit/>
           </a:bodyPr>
           <a:lstStyle/>
@@ -5068,10 +5277,16 @@
                 <a:solidFill>
                   <a:srgbClr val="FFFFFF"/>
                 </a:solidFill>
-                <a:latin typeface="Trebuchet MS"/>
+                <a:latin typeface="Trebuchet MS" panose="020B0603020202020204"/>
               </a:rPr>
               <a:t>Data &amp; preprocessing rigor</a:t>
             </a:r>
+            <a:endParaRPr sz="3000" b="1" i="0">
+              <a:solidFill>
+                <a:srgbClr val="FFFFFF"/>
+              </a:solidFill>
+              <a:latin typeface="Trebuchet MS" panose="020B0603020202020204"/>
+            </a:endParaRPr>
           </a:p>
         </p:txBody>
       </p:sp>
@@ -5136,7 +5351,7 @@
           <a:noFill/>
         </p:spPr>
         <p:txBody>
-          <a:bodyPr wrap="square" lIns="45720" rIns="45720" tIns="27432" bIns="27432">
+          <a:bodyPr wrap="square" lIns="45720" tIns="27432" rIns="45720" bIns="27432">
             <a:spAutoFit/>
           </a:bodyPr>
           <a:lstStyle/>
@@ -5151,10 +5366,16 @@
                 <a:solidFill>
                   <a:srgbClr val="1AB3A3"/>
                 </a:solidFill>
-                <a:latin typeface="Trebuchet MS"/>
+                <a:latin typeface="Trebuchet MS" panose="020B0603020202020204"/>
               </a:rPr>
               <a:t>3,651</a:t>
             </a:r>
+            <a:endParaRPr sz="4000" b="1" i="0">
+              <a:solidFill>
+                <a:srgbClr val="1AB3A3"/>
+              </a:solidFill>
+              <a:latin typeface="Trebuchet MS" panose="020B0603020202020204"/>
+            </a:endParaRPr>
           </a:p>
           <a:p>
             <a:pPr algn="ctr">
@@ -5167,10 +5388,16 @@
                 <a:solidFill>
                   <a:srgbClr val="CADCFC"/>
                 </a:solidFill>
-                <a:latin typeface="Calibri"/>
+                <a:latin typeface="Calibri" panose="020F0502020204030204"/>
               </a:rPr>
               <a:t>product images</a:t>
             </a:r>
+            <a:endParaRPr sz="1400" b="0" i="0">
+              <a:solidFill>
+                <a:srgbClr val="CADCFC"/>
+              </a:solidFill>
+              <a:latin typeface="Calibri" panose="020F0502020204030204"/>
+            </a:endParaRPr>
           </a:p>
         </p:txBody>
       </p:sp>
@@ -5235,7 +5462,7 @@
           <a:noFill/>
         </p:spPr>
         <p:txBody>
-          <a:bodyPr wrap="square" lIns="45720" rIns="45720" tIns="27432" bIns="27432">
+          <a:bodyPr wrap="square" lIns="45720" tIns="27432" rIns="45720" bIns="27432">
             <a:spAutoFit/>
           </a:bodyPr>
           <a:lstStyle/>
@@ -5250,10 +5477,16 @@
                 <a:solidFill>
                   <a:srgbClr val="1AB3A3"/>
                 </a:solidFill>
-                <a:latin typeface="Trebuchet MS"/>
+                <a:latin typeface="Trebuchet MS" panose="020B0603020202020204"/>
               </a:rPr>
               <a:t>5</a:t>
             </a:r>
+            <a:endParaRPr sz="4000" b="1" i="0">
+              <a:solidFill>
+                <a:srgbClr val="1AB3A3"/>
+              </a:solidFill>
+              <a:latin typeface="Trebuchet MS" panose="020B0603020202020204"/>
+            </a:endParaRPr>
           </a:p>
           <a:p>
             <a:pPr algn="ctr">
@@ -5266,10 +5499,16 @@
                 <a:solidFill>
                   <a:srgbClr val="CADCFC"/>
                 </a:solidFill>
-                <a:latin typeface="Calibri"/>
+                <a:latin typeface="Calibri" panose="020F0502020204030204"/>
               </a:rPr>
               <a:t>categories</a:t>
             </a:r>
+            <a:endParaRPr sz="1400" b="0" i="0">
+              <a:solidFill>
+                <a:srgbClr val="CADCFC"/>
+              </a:solidFill>
+              <a:latin typeface="Calibri" panose="020F0502020204030204"/>
+            </a:endParaRPr>
           </a:p>
         </p:txBody>
       </p:sp>
@@ -5334,7 +5573,7 @@
           <a:noFill/>
         </p:spPr>
         <p:txBody>
-          <a:bodyPr wrap="square" lIns="45720" rIns="45720" tIns="27432" bIns="27432">
+          <a:bodyPr wrap="square" lIns="45720" tIns="27432" rIns="45720" bIns="27432">
             <a:spAutoFit/>
           </a:bodyPr>
           <a:lstStyle/>
@@ -5349,10 +5588,16 @@
                 <a:solidFill>
                   <a:srgbClr val="1AB3A3"/>
                 </a:solidFill>
-                <a:latin typeface="Trebuchet MS"/>
+                <a:latin typeface="Trebuchet MS" panose="020B0603020202020204"/>
               </a:rPr>
               <a:t>0</a:t>
             </a:r>
+            <a:endParaRPr sz="4000" b="1" i="0">
+              <a:solidFill>
+                <a:srgbClr val="1AB3A3"/>
+              </a:solidFill>
+              <a:latin typeface="Trebuchet MS" panose="020B0603020202020204"/>
+            </a:endParaRPr>
           </a:p>
           <a:p>
             <a:pPr algn="ctr">
@@ -5365,10 +5610,16 @@
                 <a:solidFill>
                   <a:srgbClr val="CADCFC"/>
                 </a:solidFill>
-                <a:latin typeface="Calibri"/>
+                <a:latin typeface="Calibri" panose="020F0502020204030204"/>
               </a:rPr>
               <a:t>cross-split leaks</a:t>
             </a:r>
+            <a:endParaRPr sz="1400" b="0" i="0">
+              <a:solidFill>
+                <a:srgbClr val="CADCFC"/>
+              </a:solidFill>
+              <a:latin typeface="Calibri" panose="020F0502020204030204"/>
+            </a:endParaRPr>
           </a:p>
         </p:txBody>
       </p:sp>
@@ -5433,7 +5684,7 @@
           <a:noFill/>
         </p:spPr>
         <p:txBody>
-          <a:bodyPr wrap="square" lIns="45720" rIns="45720" tIns="27432" bIns="27432">
+          <a:bodyPr wrap="square" lIns="45720" tIns="27432" rIns="45720" bIns="27432">
             <a:spAutoFit/>
           </a:bodyPr>
           <a:lstStyle/>
@@ -5448,10 +5699,16 @@
                 <a:solidFill>
                   <a:srgbClr val="1AB3A3"/>
                 </a:solidFill>
-                <a:latin typeface="Trebuchet MS"/>
+                <a:latin typeface="Trebuchet MS" panose="020B0603020202020204"/>
               </a:rPr>
               <a:t>384²</a:t>
             </a:r>
+            <a:endParaRPr sz="4000" b="1" i="0">
+              <a:solidFill>
+                <a:srgbClr val="1AB3A3"/>
+              </a:solidFill>
+              <a:latin typeface="Trebuchet MS" panose="020B0603020202020204"/>
+            </a:endParaRPr>
           </a:p>
           <a:p>
             <a:pPr algn="ctr">
@@ -5464,10 +5721,16 @@
                 <a:solidFill>
                   <a:srgbClr val="CADCFC"/>
                 </a:solidFill>
-                <a:latin typeface="Calibri"/>
+                <a:latin typeface="Calibri" panose="020F0502020204030204"/>
               </a:rPr>
               <a:t>letterbox resize</a:t>
             </a:r>
+            <a:endParaRPr sz="1400" b="0" i="0">
+              <a:solidFill>
+                <a:srgbClr val="CADCFC"/>
+              </a:solidFill>
+              <a:latin typeface="Calibri" panose="020F0502020204030204"/>
+            </a:endParaRPr>
           </a:p>
         </p:txBody>
       </p:sp>
@@ -5488,7 +5751,7 @@
           <a:noFill/>
         </p:spPr>
         <p:txBody>
-          <a:bodyPr wrap="square" lIns="45720" rIns="45720" tIns="27432" bIns="27432">
+          <a:bodyPr wrap="square" lIns="45720" tIns="27432" rIns="45720" bIns="27432">
             <a:spAutoFit/>
           </a:bodyPr>
           <a:lstStyle/>
@@ -5504,10 +5767,16 @@
                 <a:solidFill>
                   <a:srgbClr val="FFFFFF"/>
                 </a:solidFill>
-                <a:latin typeface="Calibri"/>
+                <a:latin typeface="Calibri" panose="020F0502020204030204"/>
               </a:rPr>
               <a:t>Raw dataset treated as read-only.</a:t>
             </a:r>
+            <a:endParaRPr sz="1600" b="1" i="0">
+              <a:solidFill>
+                <a:srgbClr val="FFFFFF"/>
+              </a:solidFill>
+              <a:latin typeface="Calibri" panose="020F0502020204030204"/>
+            </a:endParaRPr>
           </a:p>
           <a:p>
             <a:pPr algn="l">
@@ -5521,10 +5790,16 @@
                 <a:solidFill>
                   <a:srgbClr val="FFFFFF"/>
                 </a:solidFill>
-                <a:latin typeface="Calibri"/>
+                <a:latin typeface="Calibri" panose="020F0502020204030204"/>
               </a:rPr>
               <a:t>Aspect-preserving letterbox to 384×384 (bilinear images, nearest-neighbour masks).</a:t>
             </a:r>
+            <a:endParaRPr sz="1600" b="0" i="0">
+              <a:solidFill>
+                <a:srgbClr val="FFFFFF"/>
+              </a:solidFill>
+              <a:latin typeface="Calibri" panose="020F0502020204030204"/>
+            </a:endParaRPr>
           </a:p>
           <a:p>
             <a:pPr algn="l">
@@ -5538,10 +5813,16 @@
                 <a:solidFill>
                   <a:srgbClr val="FFFFFF"/>
                 </a:solidFill>
-                <a:latin typeface="Calibri"/>
+                <a:latin typeface="Calibri" panose="020F0502020204030204"/>
               </a:rPr>
               <a:t>MD5 + perceptual hashing across splits to detect duplicate leakage — none found.</a:t>
             </a:r>
+            <a:endParaRPr sz="1600" b="0" i="0">
+              <a:solidFill>
+                <a:srgbClr val="FFFFFF"/>
+              </a:solidFill>
+              <a:latin typeface="Calibri" panose="020F0502020204030204"/>
+            </a:endParaRPr>
           </a:p>
           <a:p>
             <a:pPr algn="l">
@@ -5555,10 +5836,16 @@
                 <a:solidFill>
                   <a:srgbClr val="FFFFFF"/>
                 </a:solidFill>
-                <a:latin typeface="Calibri"/>
+                <a:latin typeface="Calibri" panose="020F0502020204030204"/>
               </a:rPr>
               <a:t>Fit on Train(good); threshold on Validation(good); Test held out. No test labels in tuning.</a:t>
             </a:r>
+            <a:endParaRPr sz="1600" b="0" i="0">
+              <a:solidFill>
+                <a:srgbClr val="FFFFFF"/>
+              </a:solidFill>
+              <a:latin typeface="Calibri" panose="020F0502020204030204"/>
+            </a:endParaRPr>
           </a:p>
         </p:txBody>
       </p:sp>
@@ -5571,7 +5858,7 @@
 </file>
 
 <file path=ppt/slides/slide6.xml><?xml version="1.0" encoding="utf-8"?>
-<p:sld xmlns:a="http://schemas.openxmlformats.org/drawingml/2006/main" xmlns:p="http://schemas.openxmlformats.org/presentationml/2006/main" xmlns:r="http://schemas.openxmlformats.org/officeDocument/2006/relationships">
+<p:sld xmlns:a="http://schemas.openxmlformats.org/drawingml/2006/main" xmlns:r="http://schemas.openxmlformats.org/officeDocument/2006/relationships" xmlns:p="http://schemas.openxmlformats.org/presentationml/2006/main">
   <p:cSld>
     <p:bg>
       <p:bgPr>
@@ -5605,7 +5892,7 @@
           <a:noFill/>
         </p:spPr>
         <p:txBody>
-          <a:bodyPr wrap="square" lIns="45720" rIns="45720" tIns="27432" bIns="27432">
+          <a:bodyPr wrap="square" lIns="45720" tIns="27432" rIns="45720" bIns="27432">
             <a:spAutoFit/>
           </a:bodyPr>
           <a:lstStyle/>
@@ -5620,10 +5907,16 @@
                 <a:solidFill>
                   <a:srgbClr val="1F3A5F"/>
                 </a:solidFill>
-                <a:latin typeface="Trebuchet MS"/>
+                <a:latin typeface="Trebuchet MS" panose="020B0603020202020204"/>
               </a:rPr>
               <a:t>Four DINOv2 detectors + fusion</a:t>
             </a:r>
+            <a:endParaRPr sz="3000" b="1" i="0">
+              <a:solidFill>
+                <a:srgbClr val="1F3A5F"/>
+              </a:solidFill>
+              <a:latin typeface="Trebuchet MS" panose="020B0603020202020204"/>
+            </a:endParaRPr>
           </a:p>
         </p:txBody>
       </p:sp>
@@ -5688,7 +5981,7 @@
           <a:noFill/>
         </p:spPr>
         <p:txBody>
-          <a:bodyPr wrap="square" lIns="45720" rIns="45720" tIns="27432" bIns="27432">
+          <a:bodyPr wrap="square" lIns="45720" tIns="27432" rIns="45720" bIns="27432">
             <a:spAutoFit/>
           </a:bodyPr>
           <a:lstStyle/>
@@ -5703,10 +5996,16 @@
                 <a:solidFill>
                   <a:srgbClr val="1F3A5F"/>
                 </a:solidFill>
-                <a:latin typeface="Trebuchet MS"/>
+                <a:latin typeface="Trebuchet MS" panose="020B0603020202020204"/>
               </a:rPr>
               <a:t>DINOv2 Patch Memory</a:t>
             </a:r>
+            <a:endParaRPr sz="1700" b="1" i="0">
+              <a:solidFill>
+                <a:srgbClr val="1F3A5F"/>
+              </a:solidFill>
+              <a:latin typeface="Trebuchet MS" panose="020B0603020202020204"/>
+            </a:endParaRPr>
           </a:p>
           <a:p>
             <a:pPr algn="l">
@@ -5719,10 +6018,16 @@
                 <a:solidFill>
                   <a:srgbClr val="222B35"/>
                 </a:solidFill>
-                <a:latin typeface="Calibri"/>
+                <a:latin typeface="Calibri" panose="020F0502020204030204"/>
               </a:rPr>
               <a:t>Memory bank of normal DINOv2 patch tokens; cosine nearest-neighbour distance. Catches structural defects.</a:t>
             </a:r>
+            <a:endParaRPr sz="1400" b="0" i="0">
+              <a:solidFill>
+                <a:srgbClr val="222B35"/>
+              </a:solidFill>
+              <a:latin typeface="Calibri" panose="020F0502020204030204"/>
+            </a:endParaRPr>
           </a:p>
         </p:txBody>
       </p:sp>
@@ -5787,7 +6092,7 @@
           <a:noFill/>
         </p:spPr>
         <p:txBody>
-          <a:bodyPr wrap="square" lIns="45720" rIns="45720" tIns="27432" bIns="27432">
+          <a:bodyPr wrap="square" lIns="45720" tIns="27432" rIns="45720" bIns="27432">
             <a:spAutoFit/>
           </a:bodyPr>
           <a:lstStyle/>
@@ -5802,10 +6107,16 @@
                 <a:solidFill>
                   <a:srgbClr val="1F3A5F"/>
                 </a:solidFill>
-                <a:latin typeface="Trebuchet MS"/>
+                <a:latin typeface="Trebuchet MS" panose="020B0603020202020204"/>
               </a:rPr>
               <a:t>DINOv2 Region-Aware Memory</a:t>
             </a:r>
+            <a:endParaRPr sz="1700" b="1" i="0">
+              <a:solidFill>
+                <a:srgbClr val="1F3A5F"/>
+              </a:solidFill>
+              <a:latin typeface="Trebuchet MS" panose="020B0603020202020204"/>
+            </a:endParaRPr>
           </a:p>
           <a:p>
             <a:pPr algn="l">
@@ -5818,10 +6129,16 @@
                 <a:solidFill>
                   <a:srgbClr val="222B35"/>
                 </a:solidFill>
-                <a:latin typeface="Calibri"/>
+                <a:latin typeface="Calibri" panose="020F0502020204030204"/>
               </a:rPr>
               <a:t>Memory conditioned on image region — adds positional awareness. Strongest single detector.</a:t>
             </a:r>
+            <a:endParaRPr sz="1400" b="0" i="0">
+              <a:solidFill>
+                <a:srgbClr val="222B35"/>
+              </a:solidFill>
+              <a:latin typeface="Calibri" panose="020F0502020204030204"/>
+            </a:endParaRPr>
           </a:p>
         </p:txBody>
       </p:sp>
@@ -5886,7 +6203,7 @@
           <a:noFill/>
         </p:spPr>
         <p:txBody>
-          <a:bodyPr wrap="square" lIns="45720" rIns="45720" tIns="27432" bIns="27432">
+          <a:bodyPr wrap="square" lIns="45720" tIns="27432" rIns="45720" bIns="27432">
             <a:spAutoFit/>
           </a:bodyPr>
           <a:lstStyle/>
@@ -5901,10 +6218,16 @@
                 <a:solidFill>
                   <a:srgbClr val="1F3A5F"/>
                 </a:solidFill>
-                <a:latin typeface="Trebuchet MS"/>
+                <a:latin typeface="Trebuchet MS" panose="020B0603020202020204"/>
               </a:rPr>
               <a:t>DINOv2 Composition Histogram</a:t>
             </a:r>
+            <a:endParaRPr sz="1700" b="1" i="0">
+              <a:solidFill>
+                <a:srgbClr val="1F3A5F"/>
+              </a:solidFill>
+              <a:latin typeface="Trebuchet MS" panose="020B0603020202020204"/>
+            </a:endParaRPr>
           </a:p>
           <a:p>
             <a:pPr algn="l">
@@ -5917,10 +6240,16 @@
                 <a:solidFill>
                   <a:srgbClr val="222B35"/>
                 </a:solidFill>
-                <a:latin typeface="Calibri"/>
+                <a:latin typeface="Calibri" panose="020F0502020204030204"/>
               </a:rPr>
               <a:t>DINOv2 visual-word histogram scored by Mahalanobis distance. Targets logical anomalies.</a:t>
             </a:r>
+            <a:endParaRPr sz="1400" b="0" i="0">
+              <a:solidFill>
+                <a:srgbClr val="222B35"/>
+              </a:solidFill>
+              <a:latin typeface="Calibri" panose="020F0502020204030204"/>
+            </a:endParaRPr>
           </a:p>
         </p:txBody>
       </p:sp>
@@ -5985,7 +6314,7 @@
           <a:noFill/>
         </p:spPr>
         <p:txBody>
-          <a:bodyPr wrap="square" lIns="45720" rIns="45720" tIns="27432" bIns="27432">
+          <a:bodyPr wrap="square" lIns="45720" tIns="27432" rIns="45720" bIns="27432">
             <a:spAutoFit/>
           </a:bodyPr>
           <a:lstStyle/>
@@ -6000,10 +6329,16 @@
                 <a:solidFill>
                   <a:srgbClr val="1F3A5F"/>
                 </a:solidFill>
-                <a:latin typeface="Trebuchet MS"/>
+                <a:latin typeface="Trebuchet MS" panose="020B0603020202020204"/>
               </a:rPr>
               <a:t>Global Image-Stat (proxy)</a:t>
             </a:r>
+            <a:endParaRPr sz="1700" b="1" i="0">
+              <a:solidFill>
+                <a:srgbClr val="1F3A5F"/>
+              </a:solidFill>
+              <a:latin typeface="Trebuchet MS" panose="020B0603020202020204"/>
+            </a:endParaRPr>
           </a:p>
           <a:p>
             <a:pPr algn="l">
@@ -6016,10 +6351,16 @@
                 <a:solidFill>
                   <a:srgbClr val="222B35"/>
                 </a:solidFill>
-                <a:latin typeface="Calibri"/>
+                <a:latin typeface="Calibri" panose="020F0502020204030204"/>
               </a:rPr>
               <a:t>Single global descriptor vs. the normal mean. Fast image-level baseline (non-DINOv2).</a:t>
             </a:r>
+            <a:endParaRPr sz="1400" b="0" i="0">
+              <a:solidFill>
+                <a:srgbClr val="222B35"/>
+              </a:solidFill>
+              <a:latin typeface="Calibri" panose="020F0502020204030204"/>
+            </a:endParaRPr>
           </a:p>
         </p:txBody>
       </p:sp>
@@ -6084,7 +6425,7 @@
           <a:noFill/>
         </p:spPr>
         <p:txBody>
-          <a:bodyPr wrap="square" lIns="45720" rIns="45720" tIns="27432" bIns="27432">
+          <a:bodyPr wrap="square" lIns="45720" tIns="27432" rIns="45720" bIns="27432">
             <a:spAutoFit/>
           </a:bodyPr>
           <a:lstStyle/>
@@ -6099,10 +6440,16 @@
                 <a:solidFill>
                   <a:srgbClr val="1AB3A3"/>
                 </a:solidFill>
-                <a:latin typeface="Trebuchet MS"/>
+                <a:latin typeface="Trebuchet MS" panose="020B0603020202020204"/>
               </a:rPr>
               <a:t>Fusion</a:t>
             </a:r>
+            <a:endParaRPr sz="1700" b="1" i="0">
+              <a:solidFill>
+                <a:srgbClr val="1AB3A3"/>
+              </a:solidFill>
+              <a:latin typeface="Trebuchet MS" panose="020B0603020202020204"/>
+            </a:endParaRPr>
           </a:p>
           <a:p>
             <a:pPr algn="l">
@@ -6115,10 +6462,16 @@
                 <a:solidFill>
                   <a:srgbClr val="FFFFFF"/>
                 </a:solidFill>
-                <a:latin typeface="Calibri"/>
+                <a:latin typeface="Calibri" panose="020F0502020204030204"/>
               </a:rPr>
               <a:t>Each detector is z-normalised on Validation(good) only, then combined (mean / max / rank-average). Complementary detectors fused beat any single one.</a:t>
             </a:r>
+            <a:endParaRPr sz="1450" b="0" i="0">
+              <a:solidFill>
+                <a:srgbClr val="FFFFFF"/>
+              </a:solidFill>
+              <a:latin typeface="Calibri" panose="020F0502020204030204"/>
+            </a:endParaRPr>
           </a:p>
         </p:txBody>
       </p:sp>
@@ -6131,7 +6484,7 @@
 </file>
 
 <file path=ppt/slides/slide7.xml><?xml version="1.0" encoding="utf-8"?>
-<p:sld xmlns:a="http://schemas.openxmlformats.org/drawingml/2006/main" xmlns:p="http://schemas.openxmlformats.org/presentationml/2006/main" xmlns:r="http://schemas.openxmlformats.org/officeDocument/2006/relationships">
+<p:sld xmlns:a="http://schemas.openxmlformats.org/drawingml/2006/main" xmlns:r="http://schemas.openxmlformats.org/officeDocument/2006/relationships" xmlns:p="http://schemas.openxmlformats.org/presentationml/2006/main">
   <p:cSld>
     <p:bg>
       <p:bgPr>
@@ -6165,7 +6518,7 @@
           <a:noFill/>
         </p:spPr>
         <p:txBody>
-          <a:bodyPr wrap="square" lIns="45720" rIns="45720" tIns="27432" bIns="27432">
+          <a:bodyPr wrap="square" lIns="45720" tIns="27432" rIns="45720" bIns="27432">
             <a:spAutoFit/>
           </a:bodyPr>
           <a:lstStyle/>
@@ -6180,10 +6533,16 @@
                 <a:solidFill>
                   <a:srgbClr val="1F3A5F"/>
                 </a:solidFill>
-                <a:latin typeface="Trebuchet MS"/>
+                <a:latin typeface="Trebuchet MS" panose="020B0603020202020204"/>
               </a:rPr>
               <a:t>Results — fusion wins</a:t>
             </a:r>
+            <a:endParaRPr sz="3000" b="1" i="0">
+              <a:solidFill>
+                <a:srgbClr val="1F3A5F"/>
+              </a:solidFill>
+              <a:latin typeface="Trebuchet MS" panose="020B0603020202020204"/>
+            </a:endParaRPr>
           </a:p>
         </p:txBody>
       </p:sp>
@@ -6223,10 +6582,16 @@
                           <a:solidFill>
                             <a:srgbClr val="FFFFFF"/>
                           </a:solidFill>
-                          <a:latin typeface="Trebuchet MS"/>
+                          <a:latin typeface="Trebuchet MS" panose="020B0603020202020204"/>
                         </a:rPr>
                         <a:t>Method</a:t>
                       </a:r>
+                      <a:endParaRPr sz="1400" b="1">
+                        <a:solidFill>
+                          <a:srgbClr val="FFFFFF"/>
+                        </a:solidFill>
+                        <a:latin typeface="Trebuchet MS" panose="020B0603020202020204"/>
+                      </a:endParaRPr>
                     </a:p>
                   </a:txBody>
                   <a:tcPr anchor="ctr">
@@ -6246,10 +6611,16 @@
                           <a:solidFill>
                             <a:srgbClr val="FFFFFF"/>
                           </a:solidFill>
-                          <a:latin typeface="Trebuchet MS"/>
+                          <a:latin typeface="Trebuchet MS" panose="020B0603020202020204"/>
                         </a:rPr>
                         <a:t>Logical</a:t>
                       </a:r>
+                      <a:endParaRPr sz="1400" b="1">
+                        <a:solidFill>
+                          <a:srgbClr val="FFFFFF"/>
+                        </a:solidFill>
+                        <a:latin typeface="Trebuchet MS" panose="020B0603020202020204"/>
+                      </a:endParaRPr>
                     </a:p>
                   </a:txBody>
                   <a:tcPr anchor="ctr">
@@ -6269,10 +6640,16 @@
                           <a:solidFill>
                             <a:srgbClr val="FFFFFF"/>
                           </a:solidFill>
-                          <a:latin typeface="Trebuchet MS"/>
+                          <a:latin typeface="Trebuchet MS" panose="020B0603020202020204"/>
                         </a:rPr>
                         <a:t>Structural</a:t>
                       </a:r>
+                      <a:endParaRPr sz="1400" b="1">
+                        <a:solidFill>
+                          <a:srgbClr val="FFFFFF"/>
+                        </a:solidFill>
+                        <a:latin typeface="Trebuchet MS" panose="020B0603020202020204"/>
+                      </a:endParaRPr>
                     </a:p>
                   </a:txBody>
                   <a:tcPr anchor="ctr">
@@ -6292,10 +6669,16 @@
                           <a:solidFill>
                             <a:srgbClr val="FFFFFF"/>
                           </a:solidFill>
-                          <a:latin typeface="Trebuchet MS"/>
+                          <a:latin typeface="Trebuchet MS" panose="020B0603020202020204"/>
                         </a:rPr>
                         <a:t>Overall</a:t>
                       </a:r>
+                      <a:endParaRPr sz="1400" b="1">
+                        <a:solidFill>
+                          <a:srgbClr val="FFFFFF"/>
+                        </a:solidFill>
+                        <a:latin typeface="Trebuchet MS" panose="020B0603020202020204"/>
+                      </a:endParaRPr>
                     </a:p>
                   </a:txBody>
                   <a:tcPr anchor="ctr">
@@ -6317,10 +6700,16 @@
                           <a:solidFill>
                             <a:srgbClr val="1F3A5F"/>
                           </a:solidFill>
-                          <a:latin typeface="Calibri"/>
+                          <a:latin typeface="Calibri" panose="020F0502020204030204"/>
                         </a:rPr>
                         <a:t>Fusion (mean)</a:t>
                       </a:r>
+                      <a:endParaRPr sz="1300" b="1">
+                        <a:solidFill>
+                          <a:srgbClr val="1F3A5F"/>
+                        </a:solidFill>
+                        <a:latin typeface="Calibri" panose="020F0502020204030204"/>
+                      </a:endParaRPr>
                     </a:p>
                   </a:txBody>
                   <a:tcPr anchor="ctr">
@@ -6340,10 +6729,16 @@
                           <a:solidFill>
                             <a:srgbClr val="1F3A5F"/>
                           </a:solidFill>
-                          <a:latin typeface="Calibri"/>
+                          <a:latin typeface="Calibri" panose="020F0502020204030204"/>
                         </a:rPr>
                         <a:t>0.731</a:t>
                       </a:r>
+                      <a:endParaRPr sz="1300" b="1">
+                        <a:solidFill>
+                          <a:srgbClr val="1F3A5F"/>
+                        </a:solidFill>
+                        <a:latin typeface="Calibri" panose="020F0502020204030204"/>
+                      </a:endParaRPr>
                     </a:p>
                   </a:txBody>
                   <a:tcPr anchor="ctr">
@@ -6363,10 +6758,16 @@
                           <a:solidFill>
                             <a:srgbClr val="1F3A5F"/>
                           </a:solidFill>
-                          <a:latin typeface="Calibri"/>
+                          <a:latin typeface="Calibri" panose="020F0502020204030204"/>
                         </a:rPr>
                         <a:t>0.804</a:t>
                       </a:r>
+                      <a:endParaRPr sz="1300" b="1">
+                        <a:solidFill>
+                          <a:srgbClr val="1F3A5F"/>
+                        </a:solidFill>
+                        <a:latin typeface="Calibri" panose="020F0502020204030204"/>
+                      </a:endParaRPr>
                     </a:p>
                   </a:txBody>
                   <a:tcPr anchor="ctr">
@@ -6386,10 +6787,16 @@
                           <a:solidFill>
                             <a:srgbClr val="1F3A5F"/>
                           </a:solidFill>
-                          <a:latin typeface="Calibri"/>
+                          <a:latin typeface="Calibri" panose="020F0502020204030204"/>
                         </a:rPr>
                         <a:t>0.761</a:t>
                       </a:r>
+                      <a:endParaRPr sz="1300" b="1">
+                        <a:solidFill>
+                          <a:srgbClr val="1F3A5F"/>
+                        </a:solidFill>
+                        <a:latin typeface="Calibri" panose="020F0502020204030204"/>
+                      </a:endParaRPr>
                     </a:p>
                   </a:txBody>
                   <a:tcPr anchor="ctr">
@@ -6411,10 +6818,16 @@
                           <a:solidFill>
                             <a:srgbClr val="222B35"/>
                           </a:solidFill>
-                          <a:latin typeface="Calibri"/>
+                          <a:latin typeface="Calibri" panose="020F0502020204030204"/>
                         </a:rPr>
                         <a:t>DINOv2 Region-Aware</a:t>
                       </a:r>
+                      <a:endParaRPr sz="1300" b="0">
+                        <a:solidFill>
+                          <a:srgbClr val="222B35"/>
+                        </a:solidFill>
+                        <a:latin typeface="Calibri" panose="020F0502020204030204"/>
+                      </a:endParaRPr>
                     </a:p>
                   </a:txBody>
                   <a:tcPr anchor="ctr">
@@ -6434,10 +6847,16 @@
                           <a:solidFill>
                             <a:srgbClr val="222B35"/>
                           </a:solidFill>
-                          <a:latin typeface="Calibri"/>
+                          <a:latin typeface="Calibri" panose="020F0502020204030204"/>
                         </a:rPr>
                         <a:t>0.730</a:t>
                       </a:r>
+                      <a:endParaRPr sz="1300" b="0">
+                        <a:solidFill>
+                          <a:srgbClr val="222B35"/>
+                        </a:solidFill>
+                        <a:latin typeface="Calibri" panose="020F0502020204030204"/>
+                      </a:endParaRPr>
                     </a:p>
                   </a:txBody>
                   <a:tcPr anchor="ctr">
@@ -6457,10 +6876,16 @@
                           <a:solidFill>
                             <a:srgbClr val="222B35"/>
                           </a:solidFill>
-                          <a:latin typeface="Calibri"/>
+                          <a:latin typeface="Calibri" panose="020F0502020204030204"/>
                         </a:rPr>
                         <a:t>0.784</a:t>
                       </a:r>
+                      <a:endParaRPr sz="1300" b="0">
+                        <a:solidFill>
+                          <a:srgbClr val="222B35"/>
+                        </a:solidFill>
+                        <a:latin typeface="Calibri" panose="020F0502020204030204"/>
+                      </a:endParaRPr>
                     </a:p>
                   </a:txBody>
                   <a:tcPr anchor="ctr">
@@ -6480,10 +6905,16 @@
                           <a:solidFill>
                             <a:srgbClr val="222B35"/>
                           </a:solidFill>
-                          <a:latin typeface="Calibri"/>
+                          <a:latin typeface="Calibri" panose="020F0502020204030204"/>
                         </a:rPr>
                         <a:t>0.750</a:t>
                       </a:r>
+                      <a:endParaRPr sz="1300" b="0">
+                        <a:solidFill>
+                          <a:srgbClr val="222B35"/>
+                        </a:solidFill>
+                        <a:latin typeface="Calibri" panose="020F0502020204030204"/>
+                      </a:endParaRPr>
                     </a:p>
                   </a:txBody>
                   <a:tcPr anchor="ctr">
@@ -6505,10 +6936,16 @@
                           <a:solidFill>
                             <a:srgbClr val="222B35"/>
                           </a:solidFill>
-                          <a:latin typeface="Calibri"/>
+                          <a:latin typeface="Calibri" panose="020F0502020204030204"/>
                         </a:rPr>
                         <a:t>DINOv2 Patch Memory</a:t>
                       </a:r>
+                      <a:endParaRPr sz="1300" b="0">
+                        <a:solidFill>
+                          <a:srgbClr val="222B35"/>
+                        </a:solidFill>
+                        <a:latin typeface="Calibri" panose="020F0502020204030204"/>
+                      </a:endParaRPr>
                     </a:p>
                   </a:txBody>
                   <a:tcPr anchor="ctr">
@@ -6528,10 +6965,16 @@
                           <a:solidFill>
                             <a:srgbClr val="222B35"/>
                           </a:solidFill>
-                          <a:latin typeface="Calibri"/>
+                          <a:latin typeface="Calibri" panose="020F0502020204030204"/>
                         </a:rPr>
                         <a:t>0.697</a:t>
                       </a:r>
+                      <a:endParaRPr sz="1300" b="0">
+                        <a:solidFill>
+                          <a:srgbClr val="222B35"/>
+                        </a:solidFill>
+                        <a:latin typeface="Calibri" panose="020F0502020204030204"/>
+                      </a:endParaRPr>
                     </a:p>
                   </a:txBody>
                   <a:tcPr anchor="ctr">
@@ -6551,10 +6994,16 @@
                           <a:solidFill>
                             <a:srgbClr val="222B35"/>
                           </a:solidFill>
-                          <a:latin typeface="Calibri"/>
+                          <a:latin typeface="Calibri" panose="020F0502020204030204"/>
                         </a:rPr>
                         <a:t>0.765</a:t>
                       </a:r>
+                      <a:endParaRPr sz="1300" b="0">
+                        <a:solidFill>
+                          <a:srgbClr val="222B35"/>
+                        </a:solidFill>
+                        <a:latin typeface="Calibri" panose="020F0502020204030204"/>
+                      </a:endParaRPr>
                     </a:p>
                   </a:txBody>
                   <a:tcPr anchor="ctr">
@@ -6574,10 +7023,16 @@
                           <a:solidFill>
                             <a:srgbClr val="222B35"/>
                           </a:solidFill>
-                          <a:latin typeface="Calibri"/>
+                          <a:latin typeface="Calibri" panose="020F0502020204030204"/>
                         </a:rPr>
                         <a:t>0.724</a:t>
                       </a:r>
+                      <a:endParaRPr sz="1300" b="0">
+                        <a:solidFill>
+                          <a:srgbClr val="222B35"/>
+                        </a:solidFill>
+                        <a:latin typeface="Calibri" panose="020F0502020204030204"/>
+                      </a:endParaRPr>
                     </a:p>
                   </a:txBody>
                   <a:tcPr anchor="ctr">
@@ -6599,10 +7054,16 @@
                           <a:solidFill>
                             <a:srgbClr val="222B35"/>
                           </a:solidFill>
-                          <a:latin typeface="Calibri"/>
+                          <a:latin typeface="Calibri" panose="020F0502020204030204"/>
                         </a:rPr>
                         <a:t>Composition Histogram</a:t>
                       </a:r>
+                      <a:endParaRPr sz="1300" b="0">
+                        <a:solidFill>
+                          <a:srgbClr val="222B35"/>
+                        </a:solidFill>
+                        <a:latin typeface="Calibri" panose="020F0502020204030204"/>
+                      </a:endParaRPr>
                     </a:p>
                   </a:txBody>
                   <a:tcPr anchor="ctr">
@@ -6622,10 +7083,16 @@
                           <a:solidFill>
                             <a:srgbClr val="222B35"/>
                           </a:solidFill>
-                          <a:latin typeface="Calibri"/>
+                          <a:latin typeface="Calibri" panose="020F0502020204030204"/>
                         </a:rPr>
                         <a:t>0.644</a:t>
                       </a:r>
+                      <a:endParaRPr sz="1300" b="0">
+                        <a:solidFill>
+                          <a:srgbClr val="222B35"/>
+                        </a:solidFill>
+                        <a:latin typeface="Calibri" panose="020F0502020204030204"/>
+                      </a:endParaRPr>
                     </a:p>
                   </a:txBody>
                   <a:tcPr anchor="ctr">
@@ -6645,10 +7112,16 @@
                           <a:solidFill>
                             <a:srgbClr val="222B35"/>
                           </a:solidFill>
-                          <a:latin typeface="Calibri"/>
+                          <a:latin typeface="Calibri" panose="020F0502020204030204"/>
                         </a:rPr>
                         <a:t>0.498</a:t>
                       </a:r>
+                      <a:endParaRPr sz="1300" b="0">
+                        <a:solidFill>
+                          <a:srgbClr val="222B35"/>
+                        </a:solidFill>
+                        <a:latin typeface="Calibri" panose="020F0502020204030204"/>
+                      </a:endParaRPr>
                     </a:p>
                   </a:txBody>
                   <a:tcPr anchor="ctr">
@@ -6668,10 +7141,16 @@
                           <a:solidFill>
                             <a:srgbClr val="222B35"/>
                           </a:solidFill>
-                          <a:latin typeface="Calibri"/>
+                          <a:latin typeface="Calibri" panose="020F0502020204030204"/>
                         </a:rPr>
                         <a:t>0.576</a:t>
                       </a:r>
+                      <a:endParaRPr sz="1300" b="0">
+                        <a:solidFill>
+                          <a:srgbClr val="222B35"/>
+                        </a:solidFill>
+                        <a:latin typeface="Calibri" panose="020F0502020204030204"/>
+                      </a:endParaRPr>
                     </a:p>
                   </a:txBody>
                   <a:tcPr anchor="ctr">
@@ -6693,10 +7172,16 @@
                           <a:solidFill>
                             <a:srgbClr val="222B35"/>
                           </a:solidFill>
-                          <a:latin typeface="Calibri"/>
+                          <a:latin typeface="Calibri" panose="020F0502020204030204"/>
                         </a:rPr>
                         <a:t>Global Image-Stat (proxy)</a:t>
                       </a:r>
+                      <a:endParaRPr sz="1300" b="0">
+                        <a:solidFill>
+                          <a:srgbClr val="222B35"/>
+                        </a:solidFill>
+                        <a:latin typeface="Calibri" panose="020F0502020204030204"/>
+                      </a:endParaRPr>
                     </a:p>
                   </a:txBody>
                   <a:tcPr anchor="ctr">
@@ -6716,10 +7201,16 @@
                           <a:solidFill>
                             <a:srgbClr val="222B35"/>
                           </a:solidFill>
-                          <a:latin typeface="Calibri"/>
+                          <a:latin typeface="Calibri" panose="020F0502020204030204"/>
                         </a:rPr>
                         <a:t>0.634</a:t>
                       </a:r>
+                      <a:endParaRPr sz="1300" b="0">
+                        <a:solidFill>
+                          <a:srgbClr val="222B35"/>
+                        </a:solidFill>
+                        <a:latin typeface="Calibri" panose="020F0502020204030204"/>
+                      </a:endParaRPr>
                     </a:p>
                   </a:txBody>
                   <a:tcPr anchor="ctr">
@@ -6739,10 +7230,16 @@
                           <a:solidFill>
                             <a:srgbClr val="222B35"/>
                           </a:solidFill>
-                          <a:latin typeface="Calibri"/>
+                          <a:latin typeface="Calibri" panose="020F0502020204030204"/>
                         </a:rPr>
                         <a:t>0.683</a:t>
                       </a:r>
+                      <a:endParaRPr sz="1300" b="0">
+                        <a:solidFill>
+                          <a:srgbClr val="222B35"/>
+                        </a:solidFill>
+                        <a:latin typeface="Calibri" panose="020F0502020204030204"/>
+                      </a:endParaRPr>
                     </a:p>
                   </a:txBody>
                   <a:tcPr anchor="ctr">
@@ -6762,10 +7259,16 @@
                           <a:solidFill>
                             <a:srgbClr val="222B35"/>
                           </a:solidFill>
-                          <a:latin typeface="Calibri"/>
+                          <a:latin typeface="Calibri" panose="020F0502020204030204"/>
                         </a:rPr>
                         <a:t>0.655</a:t>
                       </a:r>
+                      <a:endParaRPr sz="1300" b="0">
+                        <a:solidFill>
+                          <a:srgbClr val="222B35"/>
+                        </a:solidFill>
+                        <a:latin typeface="Calibri" panose="020F0502020204030204"/>
+                      </a:endParaRPr>
                     </a:p>
                   </a:txBody>
                   <a:tcPr anchor="ctr">
@@ -6796,7 +7299,7 @@
           <a:noFill/>
         </p:spPr>
         <p:txBody>
-          <a:bodyPr wrap="square" lIns="45720" rIns="45720" tIns="27432" bIns="27432">
+          <a:bodyPr wrap="square" lIns="45720" tIns="27432" rIns="45720" bIns="27432">
             <a:spAutoFit/>
           </a:bodyPr>
           <a:lstStyle/>
@@ -6811,10 +7314,16 @@
                 <a:solidFill>
                   <a:srgbClr val="5A6774"/>
                 </a:solidFill>
-                <a:latin typeface="Calibri"/>
+                <a:latin typeface="Calibri" panose="020F0502020204030204"/>
               </a:rPr>
               <a:t>Image-level AUROC, averaged over 5 categories.</a:t>
             </a:r>
+            <a:endParaRPr sz="1300" b="0" i="1">
+              <a:solidFill>
+                <a:srgbClr val="5A6774"/>
+              </a:solidFill>
+              <a:latin typeface="Calibri" panose="020F0502020204030204"/>
+            </a:endParaRPr>
           </a:p>
           <a:p>
             <a:pPr algn="l">
@@ -6828,10 +7337,16 @@
                 <a:solidFill>
                   <a:srgbClr val="222B35"/>
                 </a:solidFill>
-                <a:latin typeface="Calibri"/>
+                <a:latin typeface="Calibri" panose="020F0502020204030204"/>
               </a:rPr>
               <a:t>Fusing a local detector with a global one beats either alone.</a:t>
             </a:r>
+            <a:endParaRPr sz="1550" b="0" i="0">
+              <a:solidFill>
+                <a:srgbClr val="222B35"/>
+              </a:solidFill>
+              <a:latin typeface="Calibri" panose="020F0502020204030204"/>
+            </a:endParaRPr>
           </a:p>
           <a:p>
             <a:pPr algn="l">
@@ -6845,10 +7360,16 @@
                 <a:solidFill>
                   <a:srgbClr val="222B35"/>
                 </a:solidFill>
-                <a:latin typeface="Calibri"/>
+                <a:latin typeface="Calibri" panose="020F0502020204030204"/>
               </a:rPr>
               <a:t>Region-aware memory is the strongest single detector and leads on structural.</a:t>
             </a:r>
+            <a:endParaRPr sz="1550" b="0" i="0">
+              <a:solidFill>
+                <a:srgbClr val="222B35"/>
+              </a:solidFill>
+              <a:latin typeface="Calibri" panose="020F0502020204030204"/>
+            </a:endParaRPr>
           </a:p>
           <a:p>
             <a:pPr algn="l">
@@ -6862,10 +7383,16 @@
                 <a:solidFill>
                   <a:srgbClr val="222B35"/>
                 </a:solidFill>
-                <a:latin typeface="Calibri"/>
+                <a:latin typeface="Calibri" panose="020F0502020204030204"/>
               </a:rPr>
               <a:t>Real frozen DINOv2-small features — verified end-to-end and fully reproducible.</a:t>
             </a:r>
+            <a:endParaRPr sz="1550" b="0" i="0">
+              <a:solidFill>
+                <a:srgbClr val="222B35"/>
+              </a:solidFill>
+              <a:latin typeface="Calibri" panose="020F0502020204030204"/>
+            </a:endParaRPr>
           </a:p>
         </p:txBody>
       </p:sp>
@@ -6878,7 +7405,7 @@
 </file>
 
 <file path=ppt/slides/slide8.xml><?xml version="1.0" encoding="utf-8"?>
-<p:sld xmlns:a="http://schemas.openxmlformats.org/drawingml/2006/main" xmlns:p="http://schemas.openxmlformats.org/presentationml/2006/main" xmlns:r="http://schemas.openxmlformats.org/officeDocument/2006/relationships">
+<p:sld xmlns:a="http://schemas.openxmlformats.org/drawingml/2006/main" xmlns:r="http://schemas.openxmlformats.org/officeDocument/2006/relationships" xmlns:p="http://schemas.openxmlformats.org/presentationml/2006/main">
   <p:cSld>
     <p:bg>
       <p:bgPr>
@@ -6912,7 +7439,7 @@
           <a:noFill/>
         </p:spPr>
         <p:txBody>
-          <a:bodyPr wrap="square" lIns="45720" rIns="45720" tIns="27432" bIns="27432">
+          <a:bodyPr wrap="square" lIns="45720" tIns="27432" rIns="45720" bIns="27432">
             <a:spAutoFit/>
           </a:bodyPr>
           <a:lstStyle/>
@@ -6927,10 +7454,16 @@
                 <a:solidFill>
                   <a:srgbClr val="1F3A5F"/>
                 </a:solidFill>
-                <a:latin typeface="Trebuchet MS"/>
+                <a:latin typeface="Trebuchet MS" panose="020B0603020202020204"/>
               </a:rPr>
               <a:t>Feature selection — fewer, better representations</a:t>
             </a:r>
+            <a:endParaRPr sz="3000" b="1" i="0">
+              <a:solidFill>
+                <a:srgbClr val="1F3A5F"/>
+              </a:solidFill>
+              <a:latin typeface="Trebuchet MS" panose="020B0603020202020204"/>
+            </a:endParaRPr>
           </a:p>
         </p:txBody>
       </p:sp>
@@ -6951,7 +7484,7 @@
           <a:noFill/>
         </p:spPr>
         <p:txBody>
-          <a:bodyPr wrap="square" lIns="45720" rIns="45720" tIns="27432" bIns="27432">
+          <a:bodyPr wrap="square" lIns="45720" tIns="27432" rIns="45720" bIns="27432">
             <a:spAutoFit/>
           </a:bodyPr>
           <a:lstStyle/>
@@ -6966,10 +7499,16 @@
                 <a:solidFill>
                   <a:srgbClr val="222B35"/>
                 </a:solidFill>
-                <a:latin typeface="Calibri"/>
+                <a:latin typeface="Calibri" panose="020F0502020204030204"/>
               </a:rPr>
               <a:t>Each detector is a feature representation of the image. We rank them by single-branch AUROC and by leave-one-out contribution to the fusion.</a:t>
             </a:r>
+            <a:endParaRPr sz="1550" b="0" i="0">
+              <a:solidFill>
+                <a:srgbClr val="222B35"/>
+              </a:solidFill>
+              <a:latin typeface="Calibri" panose="020F0502020204030204"/>
+            </a:endParaRPr>
           </a:p>
           <a:p>
             <a:pPr algn="l">
@@ -6983,10 +7522,16 @@
                 <a:solidFill>
                   <a:srgbClr val="222B35"/>
                 </a:solidFill>
-                <a:latin typeface="Calibri"/>
+                <a:latin typeface="Calibri" panose="020F0502020204030204"/>
               </a:rPr>
               <a:t>PatchCore is byte-identical to DINOv2 PatchMemory — a redundant duplicate.</a:t>
             </a:r>
+            <a:endParaRPr sz="1550" b="0" i="0">
+              <a:solidFill>
+                <a:srgbClr val="222B35"/>
+              </a:solidFill>
+              <a:latin typeface="Calibri" panose="020F0502020204030204"/>
+            </a:endParaRPr>
           </a:p>
           <a:p>
             <a:pPr algn="l">
@@ -7000,10 +7545,16 @@
                 <a:solidFill>
                   <a:srgbClr val="222B35"/>
                 </a:solidFill>
-                <a:latin typeface="Calibri"/>
+                <a:latin typeface="Calibri" panose="020F0502020204030204"/>
               </a:rPr>
               <a:t>The Composition-Histogram branch is the only one that hurts the fusion (Δ &lt; 0).</a:t>
             </a:r>
+            <a:endParaRPr sz="1550" b="0" i="0">
+              <a:solidFill>
+                <a:srgbClr val="222B35"/>
+              </a:solidFill>
+              <a:latin typeface="Calibri" panose="020F0502020204030204"/>
+            </a:endParaRPr>
           </a:p>
           <a:p>
             <a:pPr algn="l">
@@ -7017,10 +7568,16 @@
                 <a:solidFill>
                   <a:srgbClr val="1F3A5F"/>
                 </a:solidFill>
-                <a:latin typeface="Calibri"/>
+                <a:latin typeface="Calibri" panose="020F0502020204030204"/>
               </a:rPr>
               <a:t>Dropping both → a leaner 3-representation model: 0.764 overall, 0.826 structural — edging the full fusion with fewer features.</a:t>
             </a:r>
+            <a:endParaRPr sz="1600" b="1" i="0">
+              <a:solidFill>
+                <a:srgbClr val="1F3A5F"/>
+              </a:solidFill>
+              <a:latin typeface="Calibri" panose="020F0502020204030204"/>
+            </a:endParaRPr>
           </a:p>
           <a:p>
             <a:pPr algn="l">
@@ -7033,10 +7590,16 @@
                 <a:solidFill>
                   <a:srgbClr val="5A6774"/>
                 </a:solidFill>
-                <a:latin typeface="Calibri"/>
+                <a:latin typeface="Calibri" panose="020F0502020204030204"/>
               </a:rPr>
               <a:t>No anomalous validation images exist, so importance is test-assessed and reported as analysis; the headline 0.76 fusion stays pre-specified and untuned.</a:t>
             </a:r>
+            <a:endParaRPr sz="1300" b="0" i="1">
+              <a:solidFill>
+                <a:srgbClr val="5A6774"/>
+              </a:solidFill>
+              <a:latin typeface="Calibri" panose="020F0502020204030204"/>
+            </a:endParaRPr>
           </a:p>
         </p:txBody>
       </p:sp>
@@ -7049,7 +7612,7 @@
           <p:nvPr/>
         </p:nvPicPr>
         <p:blipFill>
-          <a:blip r:embed="rId2"/>
+          <a:blip r:embed="rId1"/>
           <a:stretch>
             <a:fillRect/>
           </a:stretch>
@@ -7073,7 +7636,7 @@
 </file>
 
 <file path=ppt/slides/slide9.xml><?xml version="1.0" encoding="utf-8"?>
-<p:sld xmlns:a="http://schemas.openxmlformats.org/drawingml/2006/main" xmlns:p="http://schemas.openxmlformats.org/presentationml/2006/main" xmlns:r="http://schemas.openxmlformats.org/officeDocument/2006/relationships">
+<p:sld xmlns:a="http://schemas.openxmlformats.org/drawingml/2006/main" xmlns:r="http://schemas.openxmlformats.org/officeDocument/2006/relationships" xmlns:p="http://schemas.openxmlformats.org/presentationml/2006/main">
   <p:cSld>
     <p:bg>
       <p:bgPr>
@@ -7107,7 +7670,7 @@
           <a:noFill/>
         </p:spPr>
         <p:txBody>
-          <a:bodyPr wrap="square" lIns="45720" rIns="45720" tIns="27432" bIns="27432">
+          <a:bodyPr wrap="square" lIns="45720" tIns="27432" rIns="45720" bIns="27432">
             <a:spAutoFit/>
           </a:bodyPr>
           <a:lstStyle/>
@@ -7122,10 +7685,16 @@
                 <a:solidFill>
                   <a:srgbClr val="1F3A5F"/>
                 </a:solidFill>
-                <a:latin typeface="Trebuchet MS"/>
+                <a:latin typeface="Trebuchet MS" panose="020B0603020202020204"/>
               </a:rPr>
               <a:t>An explainable, offline dashboard</a:t>
             </a:r>
+            <a:endParaRPr sz="3000" b="1" i="0">
+              <a:solidFill>
+                <a:srgbClr val="1F3A5F"/>
+              </a:solidFill>
+              <a:latin typeface="Trebuchet MS" panose="020B0603020202020204"/>
+            </a:endParaRPr>
           </a:p>
         </p:txBody>
       </p:sp>
@@ -7146,7 +7715,7 @@
           <a:noFill/>
         </p:spPr>
         <p:txBody>
-          <a:bodyPr wrap="square" lIns="45720" rIns="45720" tIns="27432" bIns="27432">
+          <a:bodyPr wrap="square" lIns="45720" tIns="27432" rIns="45720" bIns="27432">
             <a:spAutoFit/>
           </a:bodyPr>
           <a:lstStyle/>
@@ -7162,10 +7731,16 @@
                 <a:solidFill>
                   <a:srgbClr val="1F3A5F"/>
                 </a:solidFill>
-                <a:latin typeface="Trebuchet MS"/>
+                <a:latin typeface="Trebuchet MS" panose="020B0603020202020204"/>
               </a:rPr>
               <a:t>Overview</a:t>
             </a:r>
+            <a:endParaRPr sz="1700" b="1" i="0">
+              <a:solidFill>
+                <a:srgbClr val="1F3A5F"/>
+              </a:solidFill>
+              <a:latin typeface="Trebuchet MS" panose="020B0603020202020204"/>
+            </a:endParaRPr>
           </a:p>
           <a:p>
             <a:pPr algn="l">
@@ -7179,10 +7754,16 @@
                 <a:solidFill>
                   <a:srgbClr val="1F3A5F"/>
                 </a:solidFill>
-                <a:latin typeface="Trebuchet MS"/>
+                <a:latin typeface="Trebuchet MS" panose="020B0603020202020204"/>
               </a:rPr>
               <a:t>EDA (relevant only)</a:t>
             </a:r>
+            <a:endParaRPr sz="1700" b="1" i="0">
+              <a:solidFill>
+                <a:srgbClr val="1F3A5F"/>
+              </a:solidFill>
+              <a:latin typeface="Trebuchet MS" panose="020B0603020202020204"/>
+            </a:endParaRPr>
           </a:p>
           <a:p>
             <a:pPr algn="l">
@@ -7196,10 +7777,16 @@
                 <a:solidFill>
                   <a:srgbClr val="1F3A5F"/>
                 </a:solidFill>
-                <a:latin typeface="Trebuchet MS"/>
+                <a:latin typeface="Trebuchet MS" panose="020B0603020202020204"/>
               </a:rPr>
               <a:t>Leaderboard</a:t>
             </a:r>
+            <a:endParaRPr sz="1700" b="1" i="0">
+              <a:solidFill>
+                <a:srgbClr val="1F3A5F"/>
+              </a:solidFill>
+              <a:latin typeface="Trebuchet MS" panose="020B0603020202020204"/>
+            </a:endParaRPr>
           </a:p>
           <a:p>
             <a:pPr algn="l">
@@ -7213,10 +7800,16 @@
                 <a:solidFill>
                   <a:srgbClr val="1F3A5F"/>
                 </a:solidFill>
-                <a:latin typeface="Trebuchet MS"/>
+                <a:latin typeface="Trebuchet MS" panose="020B0603020202020204"/>
               </a:rPr>
               <a:t>Explainability</a:t>
             </a:r>
+            <a:endParaRPr sz="1700" b="1" i="0">
+              <a:solidFill>
+                <a:srgbClr val="1F3A5F"/>
+              </a:solidFill>
+              <a:latin typeface="Trebuchet MS" panose="020B0603020202020204"/>
+            </a:endParaRPr>
           </a:p>
           <a:p>
             <a:pPr algn="l">
@@ -7230,10 +7823,16 @@
                 <a:solidFill>
                   <a:srgbClr val="1F3A5F"/>
                 </a:solidFill>
-                <a:latin typeface="Trebuchet MS"/>
+                <a:latin typeface="Trebuchet MS" panose="020B0603020202020204"/>
               </a:rPr>
               <a:t>Per-category drill-down</a:t>
             </a:r>
+            <a:endParaRPr sz="1700" b="1" i="0">
+              <a:solidFill>
+                <a:srgbClr val="1F3A5F"/>
+              </a:solidFill>
+              <a:latin typeface="Trebuchet MS" panose="020B0603020202020204"/>
+            </a:endParaRPr>
           </a:p>
           <a:p>
             <a:pPr algn="l">
@@ -7241,15 +7840,6 @@
                 <a:spcPts val="600"/>
               </a:spcAft>
             </a:pPr>
-            <a:r>
-              <a:rPr sz="600" b="0" i="0">
-                <a:solidFill>
-                  <a:srgbClr val="5A6774"/>
-                </a:solidFill>
-                <a:latin typeface="Calibri"/>
-              </a:rPr>
-              <a:t/>
-            </a:r>
           </a:p>
           <a:p>
             <a:pPr algn="l">
@@ -7262,10 +7852,16 @@
                 <a:solidFill>
                   <a:srgbClr val="222B35"/>
                 </a:solidFill>
-                <a:latin typeface="Calibri"/>
+                <a:latin typeface="Calibri" panose="020F0502020204030204"/>
               </a:rPr>
               <a:t>One self-contained HTML file. Opens in any browser, fully offline — no install, no server, no internet. Every decision shows image, ground-truth, score vs. threshold, ✓/✗.</a:t>
             </a:r>
+            <a:endParaRPr sz="1500" b="0" i="0">
+              <a:solidFill>
+                <a:srgbClr val="222B35"/>
+              </a:solidFill>
+              <a:latin typeface="Calibri" panose="020F0502020204030204"/>
+            </a:endParaRPr>
           </a:p>
         </p:txBody>
       </p:sp>
@@ -7278,7 +7874,7 @@
           <p:nvPr/>
         </p:nvPicPr>
         <p:blipFill>
-          <a:blip r:embed="rId2"/>
+          <a:blip r:embed="rId1"/>
           <a:stretch>
             <a:fillRect/>
           </a:stretch>
@@ -7617,6 +8213,10 @@
       </a:style>
     </a:lnDef>
   </a:objectDefaults>
-  <a:extraClrSchemeLst/>
+  <a:extLst>
+    <a:ext uri="{05A4C25C-085E-4340-85A3-A5531E510DB2}">
+      <thm15:themeFamily xmlns:thm15="http://schemas.microsoft.com/office/thememl/2012/main" name="Office Theme" id="{62F939B6-93AF-4DB8-9C6B-D6C7DFDC589F}" vid="{4A3C46E8-61CC-4603-A589-7422A47A8E4A}"/>
+    </a:ext>
+  </a:extLst>
 </a:theme>
 </file>
</xml_diff>